<commit_message>
Add real farm photos + HBP peat-moss slide to Vietnam deck
Integrates four authentic Song Young Shin Farm photos (grass-fed Jersey herd
at the feed rail, the A2 product lineup, hay-milk bottle, A2 ice cream) into
the farm and A2 slides, and adds a new HBP peat-moss bedding slide after D2O
(high absorption, animal welfare, pathogen control, closing the nutrient
loop) — extending the eco-friendly / circular-agriculture story. Deck is now
21 slides across HTML (with motion), PDF and editable PPTX.

Also fixes a latent layout bug: slides using '.pad row' were stacking
vertically because '.pad' forced flex-direction:column; added a '.pad.row'
rule so those two-column slides render side by side, and bounded the farm
photo grid height so portrait images crop instead of overflowing.

Co-Authored-By: Claude Opus 4.8 <noreply@anthropic.com>
Claude-Session: https://claude.ai/code/session_01JP8oYY7M1PRQV1JwNpvKM1
</commit_message>
<xml_diff>
--- a/deliverables/vietnam-farm-visit-2026/Song-Young-Shin-Farm-Vietnam-2026.pptx
+++ b/deliverables/vietnam-farm-visit-2026/Song-Young-Shin-Farm-Vietnam-2026.pptx
@@ -25,9 +25,10 @@
     <p:sldId id="273" r:id="rId19"/>
     <p:sldId id="274" r:id="rId20"/>
     <p:sldId id="275" r:id="rId21"/>
+    <p:sldId id="276" r:id="rId22"/>
   </p:sldIdLst>
   <p:notesMasterIdLst>
-    <p:notesMasterId r:id="rId22"/>
+    <p:notesMasterId r:id="rId23"/>
   </p:notesMasterIdLst>
   <p:sldSz cx="12191695" cy="6858000"/>
   <p:notesSz cx="6858000" cy="12191695"/>
@@ -1601,6 +1602,94 @@
             <a:fld id="{F7021451-1387-4CA6-816F-3879F97B5CBC}" type="slidenum">
               <a:rPr lang="en-US"/>
               <a:t>20</a:t>
+            </a:fld>
+            <a:endParaRPr lang="en-US"/>
+          </a:p>
+        </p:txBody>
+      </p:sp>
+    </p:spTree>
+    <p:extLst>
+      <p:ext uri="{BB962C8B-B14F-4D97-AF65-F5344CB8AC3E}">
+        <p14:creationId xmlns:p14="http://schemas.microsoft.com/office/powerpoint/2010/main" val="1024086991"/>
+      </p:ext>
+    </p:extLst>
+  </p:cSld>
+  <p:clrMapOvr>
+    <a:masterClrMapping/>
+  </p:clrMapOvr>
+</p:notes>
+</file>
+
+<file path=ppt/notesSlides/notesSlide21.xml><?xml version="1.0" encoding="utf-8"?>
+<p:notes xmlns:a="http://schemas.openxmlformats.org/drawingml/2006/main" xmlns:r="http://schemas.openxmlformats.org/officeDocument/2006/relationships" xmlns:p="http://schemas.openxmlformats.org/presentationml/2006/main">
+  <p:cSld>
+    <p:spTree>
+      <p:nvGrpSpPr>
+        <p:cNvPr id="1" name=""/>
+        <p:cNvGrpSpPr/>
+        <p:nvPr/>
+      </p:nvGrpSpPr>
+      <p:grpSpPr>
+        <a:xfrm>
+          <a:off x="0" y="0"/>
+          <a:ext cx="0" cy="0"/>
+          <a:chOff x="0" y="0"/>
+          <a:chExt cx="0" cy="0"/>
+        </a:xfrm>
+      </p:grpSpPr>
+      <p:sp>
+        <p:nvSpPr>
+          <p:cNvPr id="2" name="Slide Image Placeholder 1"/>
+          <p:cNvSpPr>
+            <a:spLocks noGrp="1" noRot="1" noChangeAspect="1"/>
+          </p:cNvSpPr>
+          <p:nvPr>
+            <p:ph type="sldImg"/>
+          </p:nvPr>
+        </p:nvSpPr>
+        <p:spPr/>
+      </p:sp>
+      <p:sp>
+        <p:nvSpPr>
+          <p:cNvPr id="3" name="Notes Placeholder 2"/>
+          <p:cNvSpPr>
+            <a:spLocks noGrp="1"/>
+          </p:cNvSpPr>
+          <p:nvPr>
+            <p:ph type="body" idx="1"/>
+          </p:nvPr>
+        </p:nvSpPr>
+        <p:spPr/>
+        <p:txBody>
+          <a:bodyPr/>
+          <a:lstStyle/>
+          <a:p>
+            <a:r>
+              <a:rPr lang="en-US" dirty="0"/>
+              <a:t/>
+            </a:r>
+            <a:endParaRPr lang="en-US" dirty="0"/>
+          </a:p>
+        </p:txBody>
+      </p:sp>
+      <p:sp>
+        <p:nvSpPr>
+          <p:cNvPr id="4" name="Slide Number Placeholder 3"/>
+          <p:cNvSpPr>
+            <a:spLocks noGrp="1"/>
+          </p:cNvSpPr>
+          <p:nvPr>
+            <p:ph type="sldNum" sz="quarter" idx="10"/>
+          </p:nvPr>
+        </p:nvSpPr>
+        <p:spPr/>
+        <p:txBody>
+          <a:bodyPr/>
+          <a:lstStyle/>
+          <a:p>
+            <a:fld id="{F7021451-1387-4CA6-816F-3879F97B5CBC}" type="slidenum">
+              <a:rPr lang="en-US"/>
+              <a:t>21</a:t>
             </a:fld>
             <a:endParaRPr lang="en-US"/>
           </a:p>
@@ -2955,6 +3044,1100 @@
     <p:bg>
       <p:bgPr>
         <a:solidFill>
+          <a:srgbClr val="F6F3EA"/>
+        </a:solidFill>
+      </p:bgPr>
+    </p:bg>
+    <p:spTree>
+      <p:nvGrpSpPr>
+        <p:cNvPr id="1" name=""/>
+        <p:cNvGrpSpPr/>
+        <p:nvPr/>
+      </p:nvGrpSpPr>
+      <p:grpSpPr>
+        <a:xfrm>
+          <a:off x="0" y="0"/>
+          <a:ext cx="0" cy="0"/>
+          <a:chOff x="0" y="0"/>
+          <a:chExt cx="0" cy="0"/>
+        </a:xfrm>
+      </p:grpSpPr>
+      <p:sp>
+        <p:nvSpPr>
+          <p:cNvPr id="2" name="Text 0"/>
+          <p:cNvSpPr/>
+          <p:nvPr/>
+        </p:nvSpPr>
+        <p:spPr>
+          <a:xfrm>
+            <a:off x="566928" y="566928"/>
+            <a:ext cx="7315200" cy="292608"/>
+          </a:xfrm>
+          <a:prstGeom prst="rect">
+            <a:avLst/>
+          </a:prstGeom>
+          <a:noFill/>
+          <a:ln/>
+        </p:spPr>
+        <p:txBody>
+          <a:bodyPr wrap="square" lIns="0" tIns="0" rIns="0" bIns="0" rtlCol="0" anchor="ctr"/>
+          <a:lstStyle/>
+          <a:p>
+            <a:pPr algn="l" indent="0" marL="0">
+              <a:buNone/>
+            </a:pPr>
+            <a:r>
+              <a:rPr lang="en-US" sz="1250" b="1" spc="240" kern="0" dirty="0">
+                <a:solidFill>
+                  <a:srgbClr val="4F7D2E"/>
+                </a:solidFill>
+                <a:latin typeface="Calibri" pitchFamily="34" charset="0"/>
+                <a:ea typeface="Calibri" pitchFamily="34" charset="-122"/>
+                <a:cs typeface="Calibri" pitchFamily="34" charset="-120"/>
+              </a:rPr>
+              <a:t>SUSTAINABLE DAIRY · 송영신목장</a:t>
+            </a:r>
+            <a:endParaRPr lang="en-US" sz="1250" dirty="0"/>
+          </a:p>
+        </p:txBody>
+      </p:sp>
+      <p:sp>
+        <p:nvSpPr>
+          <p:cNvPr id="3" name="Text 1"/>
+          <p:cNvSpPr/>
+          <p:nvPr/>
+        </p:nvSpPr>
+        <p:spPr>
+          <a:xfrm>
+            <a:off x="566928" y="960120"/>
+            <a:ext cx="7315200" cy="1371600"/>
+          </a:xfrm>
+          <a:prstGeom prst="rect">
+            <a:avLst/>
+          </a:prstGeom>
+          <a:noFill/>
+          <a:ln/>
+        </p:spPr>
+        <p:txBody>
+          <a:bodyPr wrap="square" lIns="0" tIns="0" rIns="0" bIns="0" rtlCol="0" anchor="t"/>
+          <a:lstStyle/>
+          <a:p>
+            <a:pPr algn="l" indent="0" marL="0">
+              <a:lnSpc>
+                <a:spcPct val="98000"/>
+              </a:lnSpc>
+              <a:buNone/>
+            </a:pPr>
+            <a:r>
+              <a:rPr lang="en-US" sz="3600" b="1" dirty="0">
+                <a:solidFill>
+                  <a:srgbClr val="16221C"/>
+                </a:solidFill>
+                <a:latin typeface="Cambria" pitchFamily="34" charset="0"/>
+                <a:ea typeface="Cambria" pitchFamily="34" charset="-122"/>
+                <a:cs typeface="Cambria" pitchFamily="34" charset="-120"/>
+              </a:rPr>
+              <a:t>Song Young Shin Farm</a:t>
+            </a:r>
+            <a:endParaRPr lang="en-US" sz="3600" dirty="0"/>
+          </a:p>
+        </p:txBody>
+      </p:sp>
+      <p:sp>
+        <p:nvSpPr>
+          <p:cNvPr id="4" name="Text 2"/>
+          <p:cNvSpPr/>
+          <p:nvPr/>
+        </p:nvSpPr>
+        <p:spPr>
+          <a:xfrm>
+            <a:off x="566928" y="1600200"/>
+            <a:ext cx="7315200" cy="365760"/>
+          </a:xfrm>
+          <a:prstGeom prst="rect">
+            <a:avLst/>
+          </a:prstGeom>
+          <a:noFill/>
+          <a:ln/>
+        </p:spPr>
+        <p:txBody>
+          <a:bodyPr wrap="square" lIns="0" tIns="0" rIns="0" bIns="0" rtlCol="0" anchor="ctr"/>
+          <a:lstStyle/>
+          <a:p>
+            <a:pPr indent="0" marL="0">
+              <a:buNone/>
+            </a:pPr>
+            <a:r>
+              <a:rPr lang="en-US" sz="1600" b="1" dirty="0">
+                <a:solidFill>
+                  <a:srgbClr val="4F7D2E"/>
+                </a:solidFill>
+                <a:latin typeface="Calibri" pitchFamily="34" charset="0"/>
+                <a:ea typeface="Calibri" pitchFamily="34" charset="-122"/>
+                <a:cs typeface="Calibri" pitchFamily="34" charset="-120"/>
+              </a:rPr>
+              <a:t>Korea's 1st animal-welfare &amp; low-carbon certified dairy farm</a:t>
+            </a:r>
+            <a:endParaRPr lang="en-US" sz="1600" dirty="0"/>
+          </a:p>
+        </p:txBody>
+      </p:sp>
+      <p:sp>
+        <p:nvSpPr>
+          <p:cNvPr id="5" name="Text 3"/>
+          <p:cNvSpPr/>
+          <p:nvPr/>
+        </p:nvSpPr>
+        <p:spPr>
+          <a:xfrm>
+            <a:off x="566928" y="2286000"/>
+            <a:ext cx="1280160" cy="548640"/>
+          </a:xfrm>
+          <a:prstGeom prst="rect">
+            <a:avLst/>
+          </a:prstGeom>
+          <a:noFill/>
+          <a:ln/>
+        </p:spPr>
+        <p:txBody>
+          <a:bodyPr wrap="square" lIns="0" tIns="0" rIns="0" bIns="0" rtlCol="0" anchor="ctr"/>
+          <a:lstStyle/>
+          <a:p>
+            <a:pPr algn="l" indent="0" marL="0">
+              <a:buNone/>
+            </a:pPr>
+            <a:r>
+              <a:rPr lang="en-US" sz="2600" b="1" dirty="0">
+                <a:solidFill>
+                  <a:srgbClr val="4F7D2E"/>
+                </a:solidFill>
+                <a:latin typeface="Cambria" pitchFamily="34" charset="0"/>
+                <a:ea typeface="Cambria" pitchFamily="34" charset="-122"/>
+                <a:cs typeface="Cambria" pitchFamily="34" charset="-120"/>
+              </a:rPr>
+              <a:t>1st</a:t>
+            </a:r>
+            <a:endParaRPr lang="en-US" sz="2600" dirty="0"/>
+          </a:p>
+        </p:txBody>
+      </p:sp>
+      <p:sp>
+        <p:nvSpPr>
+          <p:cNvPr id="6" name="Text 4"/>
+          <p:cNvSpPr/>
+          <p:nvPr/>
+        </p:nvSpPr>
+        <p:spPr>
+          <a:xfrm>
+            <a:off x="1892808" y="2286000"/>
+            <a:ext cx="2286000" cy="640080"/>
+          </a:xfrm>
+          <a:prstGeom prst="rect">
+            <a:avLst/>
+          </a:prstGeom>
+          <a:noFill/>
+          <a:ln/>
+        </p:spPr>
+        <p:txBody>
+          <a:bodyPr wrap="square" lIns="0" tIns="0" rIns="0" bIns="0" rtlCol="0" anchor="ctr"/>
+          <a:lstStyle/>
+          <a:p>
+            <a:pPr indent="0" marL="0">
+              <a:lnSpc>
+                <a:spcPct val="95000"/>
+              </a:lnSpc>
+              <a:buNone/>
+            </a:pPr>
+            <a:r>
+              <a:rPr lang="en-US" sz="1250" b="1" dirty="0">
+                <a:solidFill>
+                  <a:srgbClr val="39463E"/>
+                </a:solidFill>
+                <a:latin typeface="Calibri" pitchFamily="34" charset="0"/>
+                <a:ea typeface="Calibri" pitchFamily="34" charset="-122"/>
+                <a:cs typeface="Calibri" pitchFamily="34" charset="-120"/>
+              </a:rPr>
+              <a:t>Animal-welfare &amp;</a:t>
+            </a:r>
+            <a:endParaRPr lang="en-US" sz="1250" dirty="0"/>
+          </a:p>
+          <a:p>
+            <a:pPr indent="0" marL="0">
+              <a:lnSpc>
+                <a:spcPct val="95000"/>
+              </a:lnSpc>
+              <a:buNone/>
+            </a:pPr>
+            <a:r>
+              <a:rPr lang="en-US" sz="1250" b="1" dirty="0">
+                <a:solidFill>
+                  <a:srgbClr val="39463E"/>
+                </a:solidFill>
+                <a:latin typeface="Calibri" pitchFamily="34" charset="0"/>
+                <a:ea typeface="Calibri" pitchFamily="34" charset="-122"/>
+                <a:cs typeface="Calibri" pitchFamily="34" charset="-120"/>
+              </a:rPr>
+              <a:t>low-carbon certified</a:t>
+            </a:r>
+            <a:endParaRPr lang="en-US" sz="1250" dirty="0"/>
+          </a:p>
+        </p:txBody>
+      </p:sp>
+      <p:sp>
+        <p:nvSpPr>
+          <p:cNvPr id="7" name="Text 5"/>
+          <p:cNvSpPr/>
+          <p:nvPr/>
+        </p:nvSpPr>
+        <p:spPr>
+          <a:xfrm>
+            <a:off x="566928" y="3246120"/>
+            <a:ext cx="1280160" cy="548640"/>
+          </a:xfrm>
+          <a:prstGeom prst="rect">
+            <a:avLst/>
+          </a:prstGeom>
+          <a:noFill/>
+          <a:ln/>
+        </p:spPr>
+        <p:txBody>
+          <a:bodyPr wrap="square" lIns="0" tIns="0" rIns="0" bIns="0" rtlCol="0" anchor="ctr"/>
+          <a:lstStyle/>
+          <a:p>
+            <a:pPr algn="l" indent="0" marL="0">
+              <a:buNone/>
+            </a:pPr>
+            <a:r>
+              <a:rPr lang="en-US" sz="2600" b="1" dirty="0">
+                <a:solidFill>
+                  <a:srgbClr val="9A6B3A"/>
+                </a:solidFill>
+                <a:latin typeface="Cambria" pitchFamily="34" charset="0"/>
+                <a:ea typeface="Cambria" pitchFamily="34" charset="-122"/>
+                <a:cs typeface="Cambria" pitchFamily="34" charset="-120"/>
+              </a:rPr>
+              <a:t>30ha</a:t>
+            </a:r>
+            <a:endParaRPr lang="en-US" sz="2600" dirty="0"/>
+          </a:p>
+        </p:txBody>
+      </p:sp>
+      <p:sp>
+        <p:nvSpPr>
+          <p:cNvPr id="8" name="Text 6"/>
+          <p:cNvSpPr/>
+          <p:nvPr/>
+        </p:nvSpPr>
+        <p:spPr>
+          <a:xfrm>
+            <a:off x="1892808" y="3246120"/>
+            <a:ext cx="2286000" cy="640080"/>
+          </a:xfrm>
+          <a:prstGeom prst="rect">
+            <a:avLst/>
+          </a:prstGeom>
+          <a:noFill/>
+          <a:ln/>
+        </p:spPr>
+        <p:txBody>
+          <a:bodyPr wrap="square" lIns="0" tIns="0" rIns="0" bIns="0" rtlCol="0" anchor="ctr"/>
+          <a:lstStyle/>
+          <a:p>
+            <a:pPr indent="0" marL="0">
+              <a:lnSpc>
+                <a:spcPct val="95000"/>
+              </a:lnSpc>
+              <a:buNone/>
+            </a:pPr>
+            <a:r>
+              <a:rPr lang="en-US" sz="1250" b="1" dirty="0">
+                <a:solidFill>
+                  <a:srgbClr val="39463E"/>
+                </a:solidFill>
+                <a:latin typeface="Calibri" pitchFamily="34" charset="0"/>
+                <a:ea typeface="Calibri" pitchFamily="34" charset="-122"/>
+                <a:cs typeface="Calibri" pitchFamily="34" charset="-120"/>
+              </a:rPr>
+              <a:t>Own grassland for</a:t>
+            </a:r>
+            <a:endParaRPr lang="en-US" sz="1250" dirty="0"/>
+          </a:p>
+          <a:p>
+            <a:pPr indent="0" marL="0">
+              <a:lnSpc>
+                <a:spcPct val="95000"/>
+              </a:lnSpc>
+              <a:buNone/>
+            </a:pPr>
+            <a:r>
+              <a:rPr lang="en-US" sz="1250" b="1" dirty="0">
+                <a:solidFill>
+                  <a:srgbClr val="39463E"/>
+                </a:solidFill>
+                <a:latin typeface="Calibri" pitchFamily="34" charset="0"/>
+                <a:ea typeface="Calibri" pitchFamily="34" charset="-122"/>
+                <a:cs typeface="Calibri" pitchFamily="34" charset="-120"/>
+              </a:rPr>
+              <a:t>home-grown feed</a:t>
+            </a:r>
+            <a:endParaRPr lang="en-US" sz="1250" dirty="0"/>
+          </a:p>
+        </p:txBody>
+      </p:sp>
+      <p:sp>
+        <p:nvSpPr>
+          <p:cNvPr id="9" name="Text 7"/>
+          <p:cNvSpPr/>
+          <p:nvPr/>
+        </p:nvSpPr>
+        <p:spPr>
+          <a:xfrm>
+            <a:off x="566928" y="4206240"/>
+            <a:ext cx="1280160" cy="548640"/>
+          </a:xfrm>
+          <a:prstGeom prst="rect">
+            <a:avLst/>
+          </a:prstGeom>
+          <a:noFill/>
+          <a:ln/>
+        </p:spPr>
+        <p:txBody>
+          <a:bodyPr wrap="square" lIns="0" tIns="0" rIns="0" bIns="0" rtlCol="0" anchor="ctr"/>
+          <a:lstStyle/>
+          <a:p>
+            <a:pPr algn="l" indent="0" marL="0">
+              <a:buNone/>
+            </a:pPr>
+            <a:r>
+              <a:rPr lang="en-US" sz="3000" b="1" dirty="0">
+                <a:solidFill>
+                  <a:srgbClr val="12857A"/>
+                </a:solidFill>
+                <a:latin typeface="Cambria" pitchFamily="34" charset="0"/>
+                <a:ea typeface="Cambria" pitchFamily="34" charset="-122"/>
+                <a:cs typeface="Cambria" pitchFamily="34" charset="-120"/>
+              </a:rPr>
+              <a:t>A2</a:t>
+            </a:r>
+            <a:endParaRPr lang="en-US" sz="3000" dirty="0"/>
+          </a:p>
+        </p:txBody>
+      </p:sp>
+      <p:sp>
+        <p:nvSpPr>
+          <p:cNvPr id="10" name="Text 8"/>
+          <p:cNvSpPr/>
+          <p:nvPr/>
+        </p:nvSpPr>
+        <p:spPr>
+          <a:xfrm>
+            <a:off x="1892808" y="4206240"/>
+            <a:ext cx="2286000" cy="640080"/>
+          </a:xfrm>
+          <a:prstGeom prst="rect">
+            <a:avLst/>
+          </a:prstGeom>
+          <a:noFill/>
+          <a:ln/>
+        </p:spPr>
+        <p:txBody>
+          <a:bodyPr wrap="square" lIns="0" tIns="0" rIns="0" bIns="0" rtlCol="0" anchor="ctr"/>
+          <a:lstStyle/>
+          <a:p>
+            <a:pPr indent="0" marL="0">
+              <a:lnSpc>
+                <a:spcPct val="95000"/>
+              </a:lnSpc>
+              <a:buNone/>
+            </a:pPr>
+            <a:r>
+              <a:rPr lang="en-US" sz="1250" b="1" dirty="0">
+                <a:solidFill>
+                  <a:srgbClr val="39463E"/>
+                </a:solidFill>
+                <a:latin typeface="Calibri" pitchFamily="34" charset="0"/>
+                <a:ea typeface="Calibri" pitchFamily="34" charset="-122"/>
+                <a:cs typeface="Calibri" pitchFamily="34" charset="-120"/>
+              </a:rPr>
+              <a:t>Grass-fed hay milk</a:t>
+            </a:r>
+            <a:endParaRPr lang="en-US" sz="1250" dirty="0"/>
+          </a:p>
+          <a:p>
+            <a:pPr indent="0" marL="0">
+              <a:lnSpc>
+                <a:spcPct val="95000"/>
+              </a:lnSpc>
+              <a:buNone/>
+            </a:pPr>
+            <a:r>
+              <a:rPr lang="en-US" sz="1250" b="1" dirty="0">
+                <a:solidFill>
+                  <a:srgbClr val="39463E"/>
+                </a:solidFill>
+                <a:latin typeface="Calibri" pitchFamily="34" charset="0"/>
+                <a:ea typeface="Calibri" pitchFamily="34" charset="-122"/>
+                <a:cs typeface="Calibri" pitchFamily="34" charset="-120"/>
+              </a:rPr>
+              <a:t>Jersey &amp; Holstein</a:t>
+            </a:r>
+            <a:endParaRPr lang="en-US" sz="1250" dirty="0"/>
+          </a:p>
+        </p:txBody>
+      </p:sp>
+      <p:sp>
+        <p:nvSpPr>
+          <p:cNvPr id="11" name="Text 9"/>
+          <p:cNvSpPr/>
+          <p:nvPr/>
+        </p:nvSpPr>
+        <p:spPr>
+          <a:xfrm>
+            <a:off x="566928" y="5166360"/>
+            <a:ext cx="1280160" cy="548640"/>
+          </a:xfrm>
+          <a:prstGeom prst="rect">
+            <a:avLst/>
+          </a:prstGeom>
+          <a:noFill/>
+          <a:ln/>
+        </p:spPr>
+        <p:txBody>
+          <a:bodyPr wrap="square" lIns="0" tIns="0" rIns="0" bIns="0" rtlCol="0" anchor="ctr"/>
+          <a:lstStyle/>
+          <a:p>
+            <a:pPr algn="l" indent="0" marL="0">
+              <a:buNone/>
+            </a:pPr>
+            <a:r>
+              <a:rPr lang="en-US" sz="3000" b="1" dirty="0">
+                <a:solidFill>
+                  <a:srgbClr val="16221C"/>
+                </a:solidFill>
+                <a:latin typeface="Cambria" pitchFamily="34" charset="0"/>
+                <a:ea typeface="Cambria" pitchFamily="34" charset="-122"/>
+                <a:cs typeface="Cambria" pitchFamily="34" charset="-120"/>
+              </a:rPr>
+              <a:t>🤖</a:t>
+            </a:r>
+            <a:endParaRPr lang="en-US" sz="3000" dirty="0"/>
+          </a:p>
+        </p:txBody>
+      </p:sp>
+      <p:sp>
+        <p:nvSpPr>
+          <p:cNvPr id="12" name="Text 10"/>
+          <p:cNvSpPr/>
+          <p:nvPr/>
+        </p:nvSpPr>
+        <p:spPr>
+          <a:xfrm>
+            <a:off x="1892808" y="5166360"/>
+            <a:ext cx="2286000" cy="640080"/>
+          </a:xfrm>
+          <a:prstGeom prst="rect">
+            <a:avLst/>
+          </a:prstGeom>
+          <a:noFill/>
+          <a:ln/>
+        </p:spPr>
+        <p:txBody>
+          <a:bodyPr wrap="square" lIns="0" tIns="0" rIns="0" bIns="0" rtlCol="0" anchor="ctr"/>
+          <a:lstStyle/>
+          <a:p>
+            <a:pPr indent="0" marL="0">
+              <a:lnSpc>
+                <a:spcPct val="95000"/>
+              </a:lnSpc>
+              <a:buNone/>
+            </a:pPr>
+            <a:r>
+              <a:rPr lang="en-US" sz="1250" b="1" dirty="0">
+                <a:solidFill>
+                  <a:srgbClr val="39463E"/>
+                </a:solidFill>
+                <a:latin typeface="Calibri" pitchFamily="34" charset="0"/>
+                <a:ea typeface="Calibri" pitchFamily="34" charset="-122"/>
+                <a:cs typeface="Calibri" pitchFamily="34" charset="-120"/>
+              </a:rPr>
+              <a:t>Robotic milking —</a:t>
+            </a:r>
+            <a:endParaRPr lang="en-US" sz="1250" dirty="0"/>
+          </a:p>
+          <a:p>
+            <a:pPr indent="0" marL="0">
+              <a:lnSpc>
+                <a:spcPct val="95000"/>
+              </a:lnSpc>
+              <a:buNone/>
+            </a:pPr>
+            <a:r>
+              <a:rPr lang="en-US" sz="1250" b="1" dirty="0">
+                <a:solidFill>
+                  <a:srgbClr val="39463E"/>
+                </a:solidFill>
+                <a:latin typeface="Calibri" pitchFamily="34" charset="0"/>
+                <a:ea typeface="Calibri" pitchFamily="34" charset="-122"/>
+                <a:cs typeface="Calibri" pitchFamily="34" charset="-120"/>
+              </a:rPr>
+              <a:t>cows choose their time</a:t>
+            </a:r>
+            <a:endParaRPr lang="en-US" sz="1250" dirty="0"/>
+          </a:p>
+        </p:txBody>
+      </p:sp>
+      <p:sp>
+        <p:nvSpPr>
+          <p:cNvPr id="13" name="Shape 11"/>
+          <p:cNvSpPr/>
+          <p:nvPr/>
+        </p:nvSpPr>
+        <p:spPr>
+          <a:xfrm>
+            <a:off x="4160520" y="2240280"/>
+            <a:ext cx="3639312" cy="1965960"/>
+          </a:xfrm>
+          <a:prstGeom prst="roundRect">
+            <a:avLst>
+              <a:gd name="adj" fmla="val 4186"/>
+            </a:avLst>
+          </a:prstGeom>
+          <a:solidFill>
+            <a:srgbClr val="ECE7DA"/>
+          </a:solidFill>
+          <a:ln/>
+          <a:effectLst>
+            <a:outerShdw sx="100000" sy="100000" kx="0" ky="0" algn="bl" rotWithShape="0" blurRad="101600" dist="25400" dir="5400000">
+              <a:srgbClr val="0B140F">
+                <a:alpha val="22000"/>
+              </a:srgbClr>
+            </a:outerShdw>
+          </a:effectLst>
+        </p:spPr>
+      </p:sp>
+      <p:pic>
+        <p:nvPicPr>
+          <p:cNvPr id="14" name="Image 0" descr="/tmp/claude-0/-home-user-Dr-Ha--agent/6665ef24-eca8-582e-bc7a-8ce8fc2f76de/scratchpad/opt/aerial.jpg">    </p:cNvPr>
+          <p:cNvPicPr>
+            <a:picLocks noChangeAspect="1"/>
+          </p:cNvPicPr>
+          <p:nvPr/>
+        </p:nvPicPr>
+        <p:blipFill>
+          <a:blip r:embed="rId1"/>
+          <a:srcRect l="0" r="0" t="0" b="0"/>
+          <a:stretch/>
+        </p:blipFill>
+        <p:spPr>
+          <a:xfrm>
+            <a:off x="4178808" y="2258568"/>
+            <a:ext cx="3602736" cy="1929384"/>
+          </a:xfrm>
+          <a:prstGeom prst="rect">
+            <a:avLst/>
+          </a:prstGeom>
+        </p:spPr>
+      </p:pic>
+      <p:sp>
+        <p:nvSpPr>
+          <p:cNvPr id="15" name="Shape 12"/>
+          <p:cNvSpPr/>
+          <p:nvPr/>
+        </p:nvSpPr>
+        <p:spPr>
+          <a:xfrm>
+            <a:off x="4297680" y="2377440"/>
+            <a:ext cx="746150" cy="310896"/>
+          </a:xfrm>
+          <a:prstGeom prst="roundRect">
+            <a:avLst>
+              <a:gd name="adj" fmla="val 17647"/>
+            </a:avLst>
+          </a:prstGeom>
+          <a:solidFill>
+            <a:srgbClr val="0E1F18">
+              <a:alpha val="86000"/>
+            </a:srgbClr>
+          </a:solidFill>
+          <a:ln/>
+        </p:spPr>
+      </p:sp>
+      <p:sp>
+        <p:nvSpPr>
+          <p:cNvPr id="16" name="Text 13"/>
+          <p:cNvSpPr/>
+          <p:nvPr/>
+        </p:nvSpPr>
+        <p:spPr>
+          <a:xfrm>
+            <a:off x="4297680" y="2377440"/>
+            <a:ext cx="746150" cy="310896"/>
+          </a:xfrm>
+          <a:prstGeom prst="rect">
+            <a:avLst/>
+          </a:prstGeom>
+          <a:noFill/>
+          <a:ln/>
+        </p:spPr>
+        <p:txBody>
+          <a:bodyPr wrap="square" lIns="0" tIns="0" rIns="0" bIns="0" rtlCol="0" anchor="ctr"/>
+          <a:lstStyle/>
+          <a:p>
+            <a:pPr algn="ctr" indent="0" marL="0">
+              <a:buNone/>
+            </a:pPr>
+            <a:r>
+              <a:rPr lang="en-US" sz="950" b="1" spc="120" kern="0" dirty="0">
+                <a:solidFill>
+                  <a:srgbClr val="F6F3EA"/>
+                </a:solidFill>
+                <a:latin typeface="Calibri" pitchFamily="34" charset="0"/>
+                <a:ea typeface="Calibri" pitchFamily="34" charset="-122"/>
+                <a:cs typeface="Calibri" pitchFamily="34" charset="-120"/>
+              </a:rPr>
+              <a:t>THE FARM</a:t>
+            </a:r>
+            <a:endParaRPr lang="en-US" sz="950" dirty="0"/>
+          </a:p>
+        </p:txBody>
+      </p:sp>
+      <p:sp>
+        <p:nvSpPr>
+          <p:cNvPr id="17" name="Shape 14"/>
+          <p:cNvSpPr/>
+          <p:nvPr/>
+        </p:nvSpPr>
+        <p:spPr>
+          <a:xfrm>
+            <a:off x="7982712" y="2240280"/>
+            <a:ext cx="3639312" cy="1965960"/>
+          </a:xfrm>
+          <a:prstGeom prst="roundRect">
+            <a:avLst>
+              <a:gd name="adj" fmla="val 4186"/>
+            </a:avLst>
+          </a:prstGeom>
+          <a:solidFill>
+            <a:srgbClr val="ECE7DA"/>
+          </a:solidFill>
+          <a:ln/>
+          <a:effectLst>
+            <a:outerShdw sx="100000" sy="100000" kx="0" ky="0" algn="bl" rotWithShape="0" blurRad="101600" dist="25400" dir="5400000">
+              <a:srgbClr val="0B140F">
+                <a:alpha val="22000"/>
+              </a:srgbClr>
+            </a:outerShdw>
+          </a:effectLst>
+        </p:spPr>
+      </p:sp>
+      <p:pic>
+        <p:nvPicPr>
+          <p:cNvPr id="18" name="Image 1" descr="/tmp/claude-0/-home-user-Dr-Ha--agent/6665ef24-eca8-582e-bc7a-8ce8fc2f76de/scratchpad/opt/syjersey.jpg">    </p:cNvPr>
+          <p:cNvPicPr>
+            <a:picLocks noChangeAspect="1"/>
+          </p:cNvPicPr>
+          <p:nvPr/>
+        </p:nvPicPr>
+        <p:blipFill>
+          <a:blip r:embed="rId2"/>
+          <a:srcRect l="0" r="0" t="0" b="0"/>
+          <a:stretch/>
+        </p:blipFill>
+        <p:spPr>
+          <a:xfrm>
+            <a:off x="8001000" y="2258568"/>
+            <a:ext cx="3602736" cy="1929384"/>
+          </a:xfrm>
+          <a:prstGeom prst="rect">
+            <a:avLst/>
+          </a:prstGeom>
+        </p:spPr>
+      </p:pic>
+      <p:sp>
+        <p:nvSpPr>
+          <p:cNvPr id="19" name="Shape 15"/>
+          <p:cNvSpPr/>
+          <p:nvPr/>
+        </p:nvSpPr>
+        <p:spPr>
+          <a:xfrm>
+            <a:off x="8119872" y="2377440"/>
+            <a:ext cx="1720901" cy="310896"/>
+          </a:xfrm>
+          <a:prstGeom prst="roundRect">
+            <a:avLst>
+              <a:gd name="adj" fmla="val 17647"/>
+            </a:avLst>
+          </a:prstGeom>
+          <a:solidFill>
+            <a:srgbClr val="0E1F18">
+              <a:alpha val="86000"/>
+            </a:srgbClr>
+          </a:solidFill>
+          <a:ln/>
+        </p:spPr>
+      </p:sp>
+      <p:sp>
+        <p:nvSpPr>
+          <p:cNvPr id="20" name="Text 16"/>
+          <p:cNvSpPr/>
+          <p:nvPr/>
+        </p:nvSpPr>
+        <p:spPr>
+          <a:xfrm>
+            <a:off x="8119872" y="2377440"/>
+            <a:ext cx="1720901" cy="310896"/>
+          </a:xfrm>
+          <a:prstGeom prst="rect">
+            <a:avLst/>
+          </a:prstGeom>
+          <a:noFill/>
+          <a:ln/>
+        </p:spPr>
+        <p:txBody>
+          <a:bodyPr wrap="square" lIns="0" tIns="0" rIns="0" bIns="0" rtlCol="0" anchor="ctr"/>
+          <a:lstStyle/>
+          <a:p>
+            <a:pPr algn="ctr" indent="0" marL="0">
+              <a:buNone/>
+            </a:pPr>
+            <a:r>
+              <a:rPr lang="en-US" sz="950" b="1" spc="120" kern="0" dirty="0">
+                <a:solidFill>
+                  <a:srgbClr val="F6F3EA"/>
+                </a:solidFill>
+                <a:latin typeface="Calibri" pitchFamily="34" charset="0"/>
+                <a:ea typeface="Calibri" pitchFamily="34" charset="-122"/>
+                <a:cs typeface="Calibri" pitchFamily="34" charset="-120"/>
+              </a:rPr>
+              <a:t>GRASS-FED JERSEY HERD</a:t>
+            </a:r>
+            <a:endParaRPr lang="en-US" sz="950" dirty="0"/>
+          </a:p>
+        </p:txBody>
+      </p:sp>
+      <p:sp>
+        <p:nvSpPr>
+          <p:cNvPr id="21" name="Shape 17"/>
+          <p:cNvSpPr/>
+          <p:nvPr/>
+        </p:nvSpPr>
+        <p:spPr>
+          <a:xfrm>
+            <a:off x="4160520" y="4389120"/>
+            <a:ext cx="3639312" cy="1965960"/>
+          </a:xfrm>
+          <a:prstGeom prst="roundRect">
+            <a:avLst>
+              <a:gd name="adj" fmla="val 4186"/>
+            </a:avLst>
+          </a:prstGeom>
+          <a:solidFill>
+            <a:srgbClr val="ECE7DA"/>
+          </a:solidFill>
+          <a:ln/>
+          <a:effectLst>
+            <a:outerShdw sx="100000" sy="100000" kx="0" ky="0" algn="bl" rotWithShape="0" blurRad="101600" dist="25400" dir="5400000">
+              <a:srgbClr val="0B140F">
+                <a:alpha val="22000"/>
+              </a:srgbClr>
+            </a:outerShdw>
+          </a:effectLst>
+        </p:spPr>
+      </p:sp>
+      <p:pic>
+        <p:nvPicPr>
+          <p:cNvPr id="22" name="Image 2" descr="/tmp/claude-0/-home-user-Dr-Ha--agent/6665ef24-eca8-582e-bc7a-8ce8fc2f76de/scratchpad/opt/grassland.jpg">    </p:cNvPr>
+          <p:cNvPicPr>
+            <a:picLocks noChangeAspect="1"/>
+          </p:cNvPicPr>
+          <p:nvPr/>
+        </p:nvPicPr>
+        <p:blipFill>
+          <a:blip r:embed="rId3"/>
+          <a:srcRect l="0" r="0" t="0" b="0"/>
+          <a:stretch/>
+        </p:blipFill>
+        <p:spPr>
+          <a:xfrm>
+            <a:off x="4178808" y="4407408"/>
+            <a:ext cx="3602736" cy="1929384"/>
+          </a:xfrm>
+          <a:prstGeom prst="rect">
+            <a:avLst/>
+          </a:prstGeom>
+        </p:spPr>
+      </p:pic>
+      <p:sp>
+        <p:nvSpPr>
+          <p:cNvPr id="23" name="Shape 18"/>
+          <p:cNvSpPr/>
+          <p:nvPr/>
+        </p:nvSpPr>
+        <p:spPr>
+          <a:xfrm>
+            <a:off x="4297680" y="4526280"/>
+            <a:ext cx="1271016" cy="310896"/>
+          </a:xfrm>
+          <a:prstGeom prst="roundRect">
+            <a:avLst>
+              <a:gd name="adj" fmla="val 17647"/>
+            </a:avLst>
+          </a:prstGeom>
+          <a:solidFill>
+            <a:srgbClr val="0E1F18">
+              <a:alpha val="86000"/>
+            </a:srgbClr>
+          </a:solidFill>
+          <a:ln/>
+        </p:spPr>
+      </p:sp>
+      <p:sp>
+        <p:nvSpPr>
+          <p:cNvPr id="24" name="Text 19"/>
+          <p:cNvSpPr/>
+          <p:nvPr/>
+        </p:nvSpPr>
+        <p:spPr>
+          <a:xfrm>
+            <a:off x="4297680" y="4526280"/>
+            <a:ext cx="1271016" cy="310896"/>
+          </a:xfrm>
+          <a:prstGeom prst="rect">
+            <a:avLst/>
+          </a:prstGeom>
+          <a:noFill/>
+          <a:ln/>
+        </p:spPr>
+        <p:txBody>
+          <a:bodyPr wrap="square" lIns="0" tIns="0" rIns="0" bIns="0" rtlCol="0" anchor="ctr"/>
+          <a:lstStyle/>
+          <a:p>
+            <a:pPr algn="ctr" indent="0" marL="0">
+              <a:buNone/>
+            </a:pPr>
+            <a:r>
+              <a:rPr lang="en-US" sz="950" b="1" spc="120" kern="0" dirty="0">
+                <a:solidFill>
+                  <a:srgbClr val="F6F3EA"/>
+                </a:solidFill>
+                <a:latin typeface="Calibri" pitchFamily="34" charset="0"/>
+                <a:ea typeface="Calibri" pitchFamily="34" charset="-122"/>
+                <a:cs typeface="Calibri" pitchFamily="34" charset="-120"/>
+              </a:rPr>
+              <a:t>30 HA GRASSLAND</a:t>
+            </a:r>
+            <a:endParaRPr lang="en-US" sz="950" dirty="0"/>
+          </a:p>
+        </p:txBody>
+      </p:sp>
+      <p:sp>
+        <p:nvSpPr>
+          <p:cNvPr id="25" name="Shape 20"/>
+          <p:cNvSpPr/>
+          <p:nvPr/>
+        </p:nvSpPr>
+        <p:spPr>
+          <a:xfrm>
+            <a:off x="7982712" y="4389120"/>
+            <a:ext cx="3639312" cy="1965960"/>
+          </a:xfrm>
+          <a:prstGeom prst="roundRect">
+            <a:avLst>
+              <a:gd name="adj" fmla="val 4186"/>
+            </a:avLst>
+          </a:prstGeom>
+          <a:solidFill>
+            <a:srgbClr val="ECE7DA"/>
+          </a:solidFill>
+          <a:ln/>
+          <a:effectLst>
+            <a:outerShdw sx="100000" sy="100000" kx="0" ky="0" algn="bl" rotWithShape="0" blurRad="101600" dist="25400" dir="5400000">
+              <a:srgbClr val="0B140F">
+                <a:alpha val="22000"/>
+              </a:srgbClr>
+            </a:outerShdw>
+          </a:effectLst>
+        </p:spPr>
+      </p:sp>
+      <p:pic>
+        <p:nvPicPr>
+          <p:cNvPr id="26" name="Image 3" descr="/tmp/claude-0/-home-user-Dr-Ha--agent/6665ef24-eca8-582e-bc7a-8ce8fc2f76de/scratchpad/opt/sylineup.jpg">    </p:cNvPr>
+          <p:cNvPicPr>
+            <a:picLocks noChangeAspect="1"/>
+          </p:cNvPicPr>
+          <p:nvPr/>
+        </p:nvPicPr>
+        <p:blipFill>
+          <a:blip r:embed="rId4"/>
+          <a:srcRect l="0" r="0" t="0" b="0"/>
+          <a:stretch/>
+        </p:blipFill>
+        <p:spPr>
+          <a:xfrm>
+            <a:off x="8001000" y="4407408"/>
+            <a:ext cx="3602736" cy="1929384"/>
+          </a:xfrm>
+          <a:prstGeom prst="rect">
+            <a:avLst/>
+          </a:prstGeom>
+        </p:spPr>
+      </p:pic>
+      <p:sp>
+        <p:nvSpPr>
+          <p:cNvPr id="27" name="Shape 21"/>
+          <p:cNvSpPr/>
+          <p:nvPr/>
+        </p:nvSpPr>
+        <p:spPr>
+          <a:xfrm>
+            <a:off x="8119872" y="4526280"/>
+            <a:ext cx="1420978" cy="310896"/>
+          </a:xfrm>
+          <a:prstGeom prst="roundRect">
+            <a:avLst>
+              <a:gd name="adj" fmla="val 17647"/>
+            </a:avLst>
+          </a:prstGeom>
+          <a:solidFill>
+            <a:srgbClr val="0E1F18">
+              <a:alpha val="86000"/>
+            </a:srgbClr>
+          </a:solidFill>
+          <a:ln/>
+        </p:spPr>
+      </p:sp>
+      <p:sp>
+        <p:nvSpPr>
+          <p:cNvPr id="28" name="Text 22"/>
+          <p:cNvSpPr/>
+          <p:nvPr/>
+        </p:nvSpPr>
+        <p:spPr>
+          <a:xfrm>
+            <a:off x="8119872" y="4526280"/>
+            <a:ext cx="1420978" cy="310896"/>
+          </a:xfrm>
+          <a:prstGeom prst="rect">
+            <a:avLst/>
+          </a:prstGeom>
+          <a:noFill/>
+          <a:ln/>
+        </p:spPr>
+        <p:txBody>
+          <a:bodyPr wrap="square" lIns="0" tIns="0" rIns="0" bIns="0" rtlCol="0" anchor="ctr"/>
+          <a:lstStyle/>
+          <a:p>
+            <a:pPr algn="ctr" indent="0" marL="0">
+              <a:buNone/>
+            </a:pPr>
+            <a:r>
+              <a:rPr lang="en-US" sz="950" b="1" spc="120" kern="0" dirty="0">
+                <a:solidFill>
+                  <a:srgbClr val="F6F3EA"/>
+                </a:solidFill>
+                <a:latin typeface="Calibri" pitchFamily="34" charset="0"/>
+                <a:ea typeface="Calibri" pitchFamily="34" charset="-122"/>
+                <a:cs typeface="Calibri" pitchFamily="34" charset="-120"/>
+              </a:rPr>
+              <a:t>A2 HAY MILK RANGE</a:t>
+            </a:r>
+            <a:endParaRPr lang="en-US" sz="950" dirty="0"/>
+          </a:p>
+        </p:txBody>
+      </p:sp>
+      <p:sp>
+        <p:nvSpPr>
+          <p:cNvPr id="29" name="Text 23"/>
+          <p:cNvSpPr/>
+          <p:nvPr/>
+        </p:nvSpPr>
+        <p:spPr>
+          <a:xfrm>
+            <a:off x="566928" y="6400800"/>
+            <a:ext cx="6400800" cy="274320"/>
+          </a:xfrm>
+          <a:prstGeom prst="rect">
+            <a:avLst/>
+          </a:prstGeom>
+          <a:noFill/>
+          <a:ln/>
+        </p:spPr>
+        <p:txBody>
+          <a:bodyPr wrap="square" lIns="0" tIns="0" rIns="0" bIns="0" rtlCol="0" anchor="ctr"/>
+          <a:lstStyle/>
+          <a:p>
+            <a:pPr indent="0" marL="0">
+              <a:buNone/>
+            </a:pPr>
+            <a:r>
+              <a:rPr lang="en-US" sz="1000" b="1" spc="200" kern="0" dirty="0">
+                <a:solidFill>
+                  <a:srgbClr val="6E7A6E"/>
+                </a:solidFill>
+                <a:latin typeface="Calibri" pitchFamily="34" charset="0"/>
+                <a:ea typeface="Calibri" pitchFamily="34" charset="-122"/>
+                <a:cs typeface="Calibri" pitchFamily="34" charset="-120"/>
+              </a:rPr>
+              <a:t>SUSTAINABLE DAIRY</a:t>
+            </a:r>
+            <a:endParaRPr lang="en-US" sz="1000" dirty="0"/>
+          </a:p>
+        </p:txBody>
+      </p:sp>
+      <p:sp>
+        <p:nvSpPr>
+          <p:cNvPr id="30" name="Text 24"/>
+          <p:cNvSpPr/>
+          <p:nvPr/>
+        </p:nvSpPr>
+        <p:spPr>
+          <a:xfrm>
+            <a:off x="11002975" y="6400800"/>
+            <a:ext cx="822960" cy="274320"/>
+          </a:xfrm>
+          <a:prstGeom prst="rect">
+            <a:avLst/>
+          </a:prstGeom>
+          <a:noFill/>
+          <a:ln/>
+        </p:spPr>
+        <p:txBody>
+          <a:bodyPr wrap="square" lIns="0" tIns="0" rIns="0" bIns="0" rtlCol="0" anchor="ctr"/>
+          <a:lstStyle/>
+          <a:p>
+            <a:pPr algn="r" indent="0" marL="0">
+              <a:buNone/>
+            </a:pPr>
+            <a:r>
+              <a:rPr lang="en-US" sz="1100" b="1" spc="200" kern="0" dirty="0">
+                <a:solidFill>
+                  <a:srgbClr val="6E7A6E"/>
+                </a:solidFill>
+                <a:latin typeface="Calibri" pitchFamily="34" charset="0"/>
+                <a:ea typeface="Calibri" pitchFamily="34" charset="-122"/>
+                <a:cs typeface="Calibri" pitchFamily="34" charset="-120"/>
+              </a:rPr>
+              <a:t>10</a:t>
+            </a:r>
+            <a:endParaRPr lang="en-US" sz="1100" dirty="0"/>
+          </a:p>
+        </p:txBody>
+      </p:sp>
+    </p:spTree>
+  </p:cSld>
+  <p:clrMapOvr>
+    <a:masterClrMapping/>
+  </p:clrMapOvr>
+</p:sld>
+</file>
+
+<file path=ppt/slides/slide11.xml><?xml version="1.0" encoding="utf-8"?>
+<p:sld xmlns:a="http://schemas.openxmlformats.org/drawingml/2006/main" xmlns:r="http://schemas.openxmlformats.org/officeDocument/2006/relationships" xmlns:p="http://schemas.openxmlformats.org/presentationml/2006/main">
+  <p:cSld name="Slide 11">
+    <p:bg>
+      <p:bgPr>
+        <a:solidFill>
           <a:srgbClr val="15291F"/>
         </a:solidFill>
       </p:bgPr>
@@ -3276,12 +4459,12 @@
         </p:nvSpPr>
         <p:spPr>
           <a:xfrm>
-            <a:off x="7818120" y="1371600"/>
-            <a:ext cx="2377440" cy="3291840"/>
+            <a:off x="7772400" y="1234440"/>
+            <a:ext cx="3913632" cy="2926080"/>
           </a:xfrm>
           <a:prstGeom prst="roundRect">
             <a:avLst>
-              <a:gd name="adj" fmla="val 3462"/>
+              <a:gd name="adj" fmla="val 2813"/>
             </a:avLst>
           </a:prstGeom>
           <a:solidFill>
@@ -3299,7 +4482,7 @@
       </p:sp>
       <p:pic>
         <p:nvPicPr>
-          <p:cNvPr id="7" name="Image 0" descr="/tmp/claude-0/-home-user-Dr-Ha--agent/6665ef24-eca8-582e-bc7a-8ce8fc2f76de/scratchpad/opt/milk.jpg">    </p:cNvPr>
+          <p:cNvPr id="7" name="Image 0" descr="/tmp/claude-0/-home-user-Dr-Ha--agent/6665ef24-eca8-582e-bc7a-8ce8fc2f76de/scratchpad/opt/sylineup.jpg">    </p:cNvPr>
           <p:cNvPicPr>
             <a:picLocks noChangeAspect="1"/>
           </p:cNvPicPr>
@@ -3312,8 +4495,8 @@
         </p:blipFill>
         <p:spPr>
           <a:xfrm>
-            <a:off x="7836408" y="1389888"/>
-            <a:ext cx="2340864" cy="3255264"/>
+            <a:off x="7790688" y="1252728"/>
+            <a:ext cx="3877056" cy="2889504"/>
           </a:xfrm>
           <a:prstGeom prst="rect">
             <a:avLst/>
@@ -3328,37 +4511,147 @@
         </p:nvSpPr>
         <p:spPr>
           <a:xfrm>
-            <a:off x="7635240" y="4892040"/>
-            <a:ext cx="4023360" cy="1234440"/>
+            <a:off x="7909560" y="1371600"/>
+            <a:ext cx="1945843" cy="310896"/>
           </a:xfrm>
           <a:prstGeom prst="roundRect">
             <a:avLst>
-              <a:gd name="adj" fmla="val 8148"/>
+              <a:gd name="adj" fmla="val 17647"/>
             </a:avLst>
           </a:prstGeom>
           <a:solidFill>
-            <a:srgbClr val="1B3227"/>
+            <a:srgbClr val="0E1F18">
+              <a:alpha val="86000"/>
+            </a:srgbClr>
           </a:solidFill>
           <a:ln/>
+        </p:spPr>
+      </p:sp>
+      <p:sp>
+        <p:nvSpPr>
+          <p:cNvPr id="9" name="Text 6"/>
+          <p:cNvSpPr/>
+          <p:nvPr/>
+        </p:nvSpPr>
+        <p:spPr>
+          <a:xfrm>
+            <a:off x="7909560" y="1371600"/>
+            <a:ext cx="1945843" cy="310896"/>
+          </a:xfrm>
+          <a:prstGeom prst="rect">
+            <a:avLst/>
+          </a:prstGeom>
+          <a:noFill/>
+          <a:ln/>
+        </p:spPr>
+        <p:txBody>
+          <a:bodyPr wrap="square" lIns="0" tIns="0" rIns="0" bIns="0" rtlCol="0" anchor="ctr"/>
+          <a:lstStyle/>
+          <a:p>
+            <a:pPr algn="ctr" indent="0" marL="0">
+              <a:buNone/>
+            </a:pPr>
+            <a:r>
+              <a:rPr lang="en-US" sz="950" b="1" spc="120" kern="0" dirty="0">
+                <a:solidFill>
+                  <a:srgbClr val="F6F3EA"/>
+                </a:solidFill>
+                <a:latin typeface="Calibri" pitchFamily="34" charset="0"/>
+                <a:ea typeface="Calibri" pitchFamily="34" charset="-122"/>
+                <a:cs typeface="Calibri" pitchFamily="34" charset="-120"/>
+              </a:rPr>
+              <a:t>SONG YOUNG SHIN A2 RANGE</a:t>
+            </a:r>
+            <a:endParaRPr lang="en-US" sz="950" dirty="0"/>
+          </a:p>
+        </p:txBody>
+      </p:sp>
+      <p:sp>
+        <p:nvSpPr>
+          <p:cNvPr id="10" name="Shape 7"/>
+          <p:cNvSpPr/>
+          <p:nvPr/>
+        </p:nvSpPr>
+        <p:spPr>
+          <a:xfrm>
+            <a:off x="7772400" y="4297680"/>
+            <a:ext cx="1874520" cy="1920240"/>
+          </a:xfrm>
+          <a:prstGeom prst="roundRect">
+            <a:avLst>
+              <a:gd name="adj" fmla="val 4390"/>
+            </a:avLst>
+          </a:prstGeom>
+          <a:solidFill>
+            <a:srgbClr val="ECE7DA"/>
+          </a:solidFill>
+          <a:ln/>
           <a:effectLst>
-            <a:outerShdw sx="100000" sy="100000" kx="0" ky="0" algn="bl" rotWithShape="0" blurRad="88900" dist="25400" dir="5400000">
+            <a:outerShdw sx="100000" sy="100000" kx="0" ky="0" algn="bl" rotWithShape="0" blurRad="101600" dist="25400" dir="5400000">
               <a:srgbClr val="0B140F">
-                <a:alpha val="16000"/>
+                <a:alpha val="22000"/>
               </a:srgbClr>
             </a:outerShdw>
           </a:effectLst>
         </p:spPr>
       </p:sp>
-      <p:sp>
-        <p:nvSpPr>
-          <p:cNvPr id="9" name="Text 6"/>
-          <p:cNvSpPr/>
-          <p:nvPr/>
-        </p:nvSpPr>
-        <p:spPr>
-          <a:xfrm>
-            <a:off x="7818120" y="5029200"/>
-            <a:ext cx="3657600" cy="320040"/>
+      <p:pic>
+        <p:nvPicPr>
+          <p:cNvPr id="11" name="Image 1" descr="/tmp/claude-0/-home-user-Dr-Ha--agent/6665ef24-eca8-582e-bc7a-8ce8fc2f76de/scratchpad/opt/syicecream.jpg">    </p:cNvPr>
+          <p:cNvPicPr>
+            <a:picLocks noChangeAspect="1"/>
+          </p:cNvPicPr>
+          <p:nvPr/>
+        </p:nvPicPr>
+        <p:blipFill>
+          <a:blip r:embed="rId2"/>
+          <a:srcRect l="0" r="0" t="0" b="0"/>
+          <a:stretch/>
+        </p:blipFill>
+        <p:spPr>
+          <a:xfrm>
+            <a:off x="7790688" y="4315968"/>
+            <a:ext cx="1837944" cy="1883664"/>
+          </a:xfrm>
+          <a:prstGeom prst="rect">
+            <a:avLst/>
+          </a:prstGeom>
+        </p:spPr>
+      </p:pic>
+      <p:sp>
+        <p:nvSpPr>
+          <p:cNvPr id="12" name="Shape 8"/>
+          <p:cNvSpPr/>
+          <p:nvPr/>
+        </p:nvSpPr>
+        <p:spPr>
+          <a:xfrm>
+            <a:off x="7882128" y="4407408"/>
+            <a:ext cx="1046074" cy="310896"/>
+          </a:xfrm>
+          <a:prstGeom prst="roundRect">
+            <a:avLst>
+              <a:gd name="adj" fmla="val 17647"/>
+            </a:avLst>
+          </a:prstGeom>
+          <a:solidFill>
+            <a:srgbClr val="0E1F18">
+              <a:alpha val="86000"/>
+            </a:srgbClr>
+          </a:solidFill>
+          <a:ln/>
+        </p:spPr>
+      </p:sp>
+      <p:sp>
+        <p:nvSpPr>
+          <p:cNvPr id="13" name="Text 9"/>
+          <p:cNvSpPr/>
+          <p:nvPr/>
+        </p:nvSpPr>
+        <p:spPr>
+          <a:xfrm>
+            <a:off x="7882128" y="4407408"/>
+            <a:ext cx="1046074" cy="310896"/>
           </a:xfrm>
           <a:prstGeom prst="rect">
             <a:avLst/>
@@ -3374,30 +4667,106 @@
               <a:buNone/>
             </a:pPr>
             <a:r>
-              <a:rPr lang="en-US" sz="1300" dirty="0">
-                <a:solidFill>
-                  <a:srgbClr val="CFE0C6"/>
-                </a:solidFill>
-                <a:latin typeface="Calibri" pitchFamily="34" charset="0"/>
-                <a:ea typeface="Calibri" pitchFamily="34" charset="-122"/>
-                <a:cs typeface="Calibri" pitchFamily="34" charset="-120"/>
-              </a:rPr>
-              <a:t>Sustainability that pays for itself</a:t>
-            </a:r>
-            <a:endParaRPr lang="en-US" sz="1300" dirty="0"/>
-          </a:p>
-        </p:txBody>
-      </p:sp>
-      <p:sp>
-        <p:nvSpPr>
-          <p:cNvPr id="10" name="Text 7"/>
-          <p:cNvSpPr/>
-          <p:nvPr/>
-        </p:nvSpPr>
-        <p:spPr>
-          <a:xfrm>
-            <a:off x="7818120" y="5394960"/>
-            <a:ext cx="3657600" cy="548640"/>
+              <a:rPr lang="en-US" sz="950" b="1" spc="120" kern="0" dirty="0">
+                <a:solidFill>
+                  <a:srgbClr val="F6F3EA"/>
+                </a:solidFill>
+                <a:latin typeface="Calibri" pitchFamily="34" charset="0"/>
+                <a:ea typeface="Calibri" pitchFamily="34" charset="-122"/>
+                <a:cs typeface="Calibri" pitchFamily="34" charset="-120"/>
+              </a:rPr>
+              <a:t>A2 ICE CREAM</a:t>
+            </a:r>
+            <a:endParaRPr lang="en-US" sz="950" dirty="0"/>
+          </a:p>
+        </p:txBody>
+      </p:sp>
+      <p:sp>
+        <p:nvSpPr>
+          <p:cNvPr id="14" name="Shape 10"/>
+          <p:cNvSpPr/>
+          <p:nvPr/>
+        </p:nvSpPr>
+        <p:spPr>
+          <a:xfrm>
+            <a:off x="9802368" y="4297680"/>
+            <a:ext cx="1883664" cy="1920240"/>
+          </a:xfrm>
+          <a:prstGeom prst="roundRect">
+            <a:avLst>
+              <a:gd name="adj" fmla="val 4369"/>
+            </a:avLst>
+          </a:prstGeom>
+          <a:solidFill>
+            <a:srgbClr val="ECE7DA"/>
+          </a:solidFill>
+          <a:ln/>
+          <a:effectLst>
+            <a:outerShdw sx="100000" sy="100000" kx="0" ky="0" algn="bl" rotWithShape="0" blurRad="101600" dist="25400" dir="5400000">
+              <a:srgbClr val="0B140F">
+                <a:alpha val="22000"/>
+              </a:srgbClr>
+            </a:outerShdw>
+          </a:effectLst>
+        </p:spPr>
+      </p:sp>
+      <p:pic>
+        <p:nvPicPr>
+          <p:cNvPr id="15" name="Image 2" descr="/tmp/claude-0/-home-user-Dr-Ha--agent/6665ef24-eca8-582e-bc7a-8ce8fc2f76de/scratchpad/opt/sybottle.jpg">    </p:cNvPr>
+          <p:cNvPicPr>
+            <a:picLocks noChangeAspect="1"/>
+          </p:cNvPicPr>
+          <p:nvPr/>
+        </p:nvPicPr>
+        <p:blipFill>
+          <a:blip r:embed="rId3"/>
+          <a:srcRect l="0" r="0" t="0" b="0"/>
+          <a:stretch/>
+        </p:blipFill>
+        <p:spPr>
+          <a:xfrm>
+            <a:off x="9820656" y="4315968"/>
+            <a:ext cx="1847088" cy="1883664"/>
+          </a:xfrm>
+          <a:prstGeom prst="rect">
+            <a:avLst/>
+          </a:prstGeom>
+        </p:spPr>
+      </p:pic>
+      <p:sp>
+        <p:nvSpPr>
+          <p:cNvPr id="16" name="Shape 11"/>
+          <p:cNvSpPr/>
+          <p:nvPr/>
+        </p:nvSpPr>
+        <p:spPr>
+          <a:xfrm>
+            <a:off x="9912096" y="4407408"/>
+            <a:ext cx="746150" cy="310896"/>
+          </a:xfrm>
+          <a:prstGeom prst="roundRect">
+            <a:avLst>
+              <a:gd name="adj" fmla="val 17647"/>
+            </a:avLst>
+          </a:prstGeom>
+          <a:solidFill>
+            <a:srgbClr val="0E1F18">
+              <a:alpha val="86000"/>
+            </a:srgbClr>
+          </a:solidFill>
+          <a:ln/>
+        </p:spPr>
+      </p:sp>
+      <p:sp>
+        <p:nvSpPr>
+          <p:cNvPr id="17" name="Text 12"/>
+          <p:cNvSpPr/>
+          <p:nvPr/>
+        </p:nvSpPr>
+        <p:spPr>
+          <a:xfrm>
+            <a:off x="9912096" y="4407408"/>
+            <a:ext cx="746150" cy="310896"/>
           </a:xfrm>
           <a:prstGeom prst="rect">
             <a:avLst/>
@@ -3410,13 +4779,49 @@
           <a:lstStyle/>
           <a:p>
             <a:pPr algn="ctr" indent="0" marL="0">
-              <a:lnSpc>
-                <a:spcPct val="100000"/>
-              </a:lnSpc>
-              <a:buNone/>
-            </a:pPr>
-            <a:r>
-              <a:rPr lang="en-US" sz="1350" b="1" dirty="0">
+              <a:buNone/>
+            </a:pPr>
+            <a:r>
+              <a:rPr lang="en-US" sz="950" b="1" spc="120" kern="0" dirty="0">
+                <a:solidFill>
+                  <a:srgbClr val="F6F3EA"/>
+                </a:solidFill>
+                <a:latin typeface="Calibri" pitchFamily="34" charset="0"/>
+                <a:ea typeface="Calibri" pitchFamily="34" charset="-122"/>
+                <a:cs typeface="Calibri" pitchFamily="34" charset="-120"/>
+              </a:rPr>
+              <a:t>HAY MILK</a:t>
+            </a:r>
+            <a:endParaRPr lang="en-US" sz="950" dirty="0"/>
+          </a:p>
+        </p:txBody>
+      </p:sp>
+      <p:sp>
+        <p:nvSpPr>
+          <p:cNvPr id="18" name="Text 13"/>
+          <p:cNvSpPr/>
+          <p:nvPr/>
+        </p:nvSpPr>
+        <p:spPr>
+          <a:xfrm>
+            <a:off x="7772400" y="6309360"/>
+            <a:ext cx="3931920" cy="320040"/>
+          </a:xfrm>
+          <a:prstGeom prst="rect">
+            <a:avLst/>
+          </a:prstGeom>
+          <a:noFill/>
+          <a:ln/>
+        </p:spPr>
+        <p:txBody>
+          <a:bodyPr wrap="square" lIns="0" tIns="0" rIns="0" bIns="0" rtlCol="0" anchor="ctr"/>
+          <a:lstStyle/>
+          <a:p>
+            <a:pPr algn="ctr" indent="0" marL="0">
+              <a:buNone/>
+            </a:pPr>
+            <a:r>
+              <a:rPr lang="en-US" sz="1150" b="1" dirty="0">
                 <a:solidFill>
                   <a:srgbClr val="9BC53D"/>
                 </a:solidFill>
@@ -3424,15 +4829,15 @@
                 <a:ea typeface="Calibri" pitchFamily="34" charset="-122"/>
                 <a:cs typeface="Calibri" pitchFamily="34" charset="-120"/>
               </a:rPr>
-              <a:t>Welfare → Quality → Premium price → Reinvestment</a:t>
-            </a:r>
-            <a:endParaRPr lang="en-US" sz="1350" dirty="0"/>
-          </a:p>
-        </p:txBody>
-      </p:sp>
-      <p:sp>
-        <p:nvSpPr>
-          <p:cNvPr id="11" name="Text 8"/>
+              <a:t>Hay milk · Yogurt · Ice cream — value added on the farm</a:t>
+            </a:r>
+            <a:endParaRPr lang="en-US" sz="1150" dirty="0"/>
+          </a:p>
+        </p:txBody>
+      </p:sp>
+      <p:sp>
+        <p:nvSpPr>
+          <p:cNvPr id="19" name="Text 14"/>
           <p:cNvSpPr/>
           <p:nvPr/>
         </p:nvSpPr>
@@ -3471,7 +4876,7 @@
       </p:sp>
       <p:sp>
         <p:nvSpPr>
-          <p:cNvPr id="12" name="Text 9"/>
+          <p:cNvPr id="20" name="Text 15"/>
           <p:cNvSpPr/>
           <p:nvPr/>
         </p:nvSpPr>
@@ -3502,7 +4907,7 @@
                 <a:ea typeface="Calibri" pitchFamily="34" charset="-122"/>
                 <a:cs typeface="Calibri" pitchFamily="34" charset="-120"/>
               </a:rPr>
-              <a:t>10</a:t>
+              <a:t>11</a:t>
             </a:r>
             <a:endParaRPr lang="en-US" sz="1100" dirty="0"/>
           </a:p>
@@ -3516,9 +4921,9 @@
 </p:sld>
 </file>
 
-<file path=ppt/slides/slide11.xml><?xml version="1.0" encoding="utf-8"?>
+<file path=ppt/slides/slide12.xml><?xml version="1.0" encoding="utf-8"?>
 <p:sld xmlns:a="http://schemas.openxmlformats.org/drawingml/2006/main" xmlns:r="http://schemas.openxmlformats.org/officeDocument/2006/relationships" xmlns:p="http://schemas.openxmlformats.org/presentationml/2006/main">
-  <p:cSld name="Slide 11">
+  <p:cSld name="Slide 12">
     <p:bg>
       <p:bgPr>
         <a:solidFill>
@@ -4462,7 +5867,7 @@
                 <a:ea typeface="Calibri" pitchFamily="34" charset="-122"/>
                 <a:cs typeface="Calibri" pitchFamily="34" charset="-120"/>
               </a:rPr>
-              <a:t>11</a:t>
+              <a:t>12</a:t>
             </a:r>
             <a:endParaRPr lang="en-US" sz="1100" dirty="0"/>
           </a:p>
@@ -4476,9 +5881,9 @@
 </p:sld>
 </file>
 
-<file path=ppt/slides/slide12.xml><?xml version="1.0" encoding="utf-8"?>
+<file path=ppt/slides/slide13.xml><?xml version="1.0" encoding="utf-8"?>
 <p:sld xmlns:a="http://schemas.openxmlformats.org/drawingml/2006/main" xmlns:r="http://schemas.openxmlformats.org/officeDocument/2006/relationships" xmlns:p="http://schemas.openxmlformats.org/presentationml/2006/main">
-  <p:cSld name="Slide 12">
+  <p:cSld name="Slide 13">
     <p:bg>
       <p:bgPr>
         <a:solidFill>
@@ -5273,7 +6678,7 @@
                 <a:ea typeface="Calibri" pitchFamily="34" charset="-122"/>
                 <a:cs typeface="Calibri" pitchFamily="34" charset="-120"/>
               </a:rPr>
-              <a:t>12</a:t>
+              <a:t>13</a:t>
             </a:r>
             <a:endParaRPr lang="en-US" sz="1100" dirty="0"/>
           </a:p>
@@ -5287,9 +6692,9 @@
 </p:sld>
 </file>
 
-<file path=ppt/slides/slide13.xml><?xml version="1.0" encoding="utf-8"?>
+<file path=ppt/slides/slide14.xml><?xml version="1.0" encoding="utf-8"?>
 <p:sld xmlns:a="http://schemas.openxmlformats.org/drawingml/2006/main" xmlns:r="http://schemas.openxmlformats.org/officeDocument/2006/relationships" xmlns:p="http://schemas.openxmlformats.org/presentationml/2006/main">
-  <p:cSld name="Slide 13">
+  <p:cSld name="Slide 14">
     <p:bg>
       <p:bgPr>
         <a:solidFill>
@@ -6150,7 +7555,7 @@
                 <a:ea typeface="Calibri" pitchFamily="34" charset="-122"/>
                 <a:cs typeface="Calibri" pitchFamily="34" charset="-120"/>
               </a:rPr>
-              <a:t>13</a:t>
+              <a:t>14</a:t>
             </a:r>
             <a:endParaRPr lang="en-US" sz="1100" dirty="0"/>
           </a:p>
@@ -6164,9 +7569,9 @@
 </p:sld>
 </file>
 
-<file path=ppt/slides/slide14.xml><?xml version="1.0" encoding="utf-8"?>
+<file path=ppt/slides/slide15.xml><?xml version="1.0" encoding="utf-8"?>
 <p:sld xmlns:a="http://schemas.openxmlformats.org/drawingml/2006/main" xmlns:r="http://schemas.openxmlformats.org/officeDocument/2006/relationships" xmlns:p="http://schemas.openxmlformats.org/presentationml/2006/main">
-  <p:cSld name="Slide 14">
+  <p:cSld name="Slide 15">
     <p:bg>
       <p:bgPr>
         <a:solidFill>
@@ -6950,7 +8355,7 @@
                 <a:ea typeface="Calibri" pitchFamily="34" charset="-122"/>
                 <a:cs typeface="Calibri" pitchFamily="34" charset="-120"/>
               </a:rPr>
-              <a:t>14</a:t>
+              <a:t>15</a:t>
             </a:r>
             <a:endParaRPr lang="en-US" sz="1100" dirty="0"/>
           </a:p>
@@ -6964,9 +8369,9 @@
 </p:sld>
 </file>
 
-<file path=ppt/slides/slide15.xml><?xml version="1.0" encoding="utf-8"?>
+<file path=ppt/slides/slide16.xml><?xml version="1.0" encoding="utf-8"?>
 <p:sld xmlns:a="http://schemas.openxmlformats.org/drawingml/2006/main" xmlns:r="http://schemas.openxmlformats.org/officeDocument/2006/relationships" xmlns:p="http://schemas.openxmlformats.org/presentationml/2006/main">
-  <p:cSld name="Slide 15">
+  <p:cSld name="Slide 16">
     <p:bg>
       <p:bgPr>
         <a:solidFill>
@@ -7799,7 +9204,7 @@
                 <a:ea typeface="Calibri" pitchFamily="34" charset="-122"/>
                 <a:cs typeface="Calibri" pitchFamily="34" charset="-120"/>
               </a:rPr>
-              <a:t>15</a:t>
+              <a:t>16</a:t>
             </a:r>
             <a:endParaRPr lang="en-US" sz="1100" dirty="0"/>
           </a:p>
@@ -7813,9 +9218,9 @@
 </p:sld>
 </file>
 
-<file path=ppt/slides/slide16.xml><?xml version="1.0" encoding="utf-8"?>
+<file path=ppt/slides/slide17.xml><?xml version="1.0" encoding="utf-8"?>
 <p:sld xmlns:a="http://schemas.openxmlformats.org/drawingml/2006/main" xmlns:r="http://schemas.openxmlformats.org/officeDocument/2006/relationships" xmlns:p="http://schemas.openxmlformats.org/presentationml/2006/main">
-  <p:cSld name="Slide 16">
+  <p:cSld name="Slide 17">
     <p:bg>
       <p:bgPr>
         <a:solidFill>
@@ -8762,7 +10167,7 @@
                 <a:ea typeface="Calibri" pitchFamily="34" charset="-122"/>
                 <a:cs typeface="Calibri" pitchFamily="34" charset="-120"/>
               </a:rPr>
-              <a:t>16</a:t>
+              <a:t>17</a:t>
             </a:r>
             <a:endParaRPr lang="en-US" sz="1100" dirty="0"/>
           </a:p>
@@ -8776,9 +10181,9 @@
 </p:sld>
 </file>
 
-<file path=ppt/slides/slide17.xml><?xml version="1.0" encoding="utf-8"?>
+<file path=ppt/slides/slide18.xml><?xml version="1.0" encoding="utf-8"?>
 <p:sld xmlns:a="http://schemas.openxmlformats.org/drawingml/2006/main" xmlns:r="http://schemas.openxmlformats.org/officeDocument/2006/relationships" xmlns:p="http://schemas.openxmlformats.org/presentationml/2006/main">
-  <p:cSld name="Slide 17">
+  <p:cSld name="Slide 18">
     <p:bg>
       <p:bgPr>
         <a:solidFill>
@@ -9640,7 +11045,7 @@
                 <a:ea typeface="Calibri" pitchFamily="34" charset="-122"/>
                 <a:cs typeface="Calibri" pitchFamily="34" charset="-120"/>
               </a:rPr>
-              <a:t>17</a:t>
+              <a:t>18</a:t>
             </a:r>
             <a:endParaRPr lang="en-US" sz="1100" dirty="0"/>
           </a:p>
@@ -9654,9 +11059,9 @@
 </p:sld>
 </file>
 
-<file path=ppt/slides/slide18.xml><?xml version="1.0" encoding="utf-8"?>
+<file path=ppt/slides/slide19.xml><?xml version="1.0" encoding="utf-8"?>
 <p:sld xmlns:a="http://schemas.openxmlformats.org/drawingml/2006/main" xmlns:r="http://schemas.openxmlformats.org/officeDocument/2006/relationships" xmlns:p="http://schemas.openxmlformats.org/presentationml/2006/main">
-  <p:cSld name="Slide 18">
+  <p:cSld name="Slide 19">
     <p:bg>
       <p:bgPr>
         <a:solidFill>
@@ -10368,596 +11773,6 @@
       <p:sp>
         <p:nvSpPr>
           <p:cNvPr id="19" name="Text 17"/>
-          <p:cNvSpPr/>
-          <p:nvPr/>
-        </p:nvSpPr>
-        <p:spPr>
-          <a:xfrm>
-            <a:off x="11002975" y="6400800"/>
-            <a:ext cx="822960" cy="274320"/>
-          </a:xfrm>
-          <a:prstGeom prst="rect">
-            <a:avLst/>
-          </a:prstGeom>
-          <a:noFill/>
-          <a:ln/>
-        </p:spPr>
-        <p:txBody>
-          <a:bodyPr wrap="square" lIns="0" tIns="0" rIns="0" bIns="0" rtlCol="0" anchor="ctr"/>
-          <a:lstStyle/>
-          <a:p>
-            <a:pPr algn="r" indent="0" marL="0">
-              <a:buNone/>
-            </a:pPr>
-            <a:r>
-              <a:rPr lang="en-US" sz="1100" b="1" spc="200" kern="0" dirty="0">
-                <a:solidFill>
-                  <a:srgbClr val="9DA99C"/>
-                </a:solidFill>
-                <a:latin typeface="Calibri" pitchFamily="34" charset="0"/>
-                <a:ea typeface="Calibri" pitchFamily="34" charset="-122"/>
-                <a:cs typeface="Calibri" pitchFamily="34" charset="-120"/>
-              </a:rPr>
-              <a:t>18</a:t>
-            </a:r>
-            <a:endParaRPr lang="en-US" sz="1100" dirty="0"/>
-          </a:p>
-        </p:txBody>
-      </p:sp>
-    </p:spTree>
-  </p:cSld>
-  <p:clrMapOvr>
-    <a:masterClrMapping/>
-  </p:clrMapOvr>
-</p:sld>
-</file>
-
-<file path=ppt/slides/slide19.xml><?xml version="1.0" encoding="utf-8"?>
-<p:sld xmlns:a="http://schemas.openxmlformats.org/drawingml/2006/main" xmlns:r="http://schemas.openxmlformats.org/officeDocument/2006/relationships" xmlns:p="http://schemas.openxmlformats.org/presentationml/2006/main">
-  <p:cSld name="Slide 19">
-    <p:bg>
-      <p:bgPr>
-        <a:blipFill dpi="0" rotWithShape="1">
-          <a:blip r:embed="rId1">
-            <a:lum/>
-          </a:blip>
-          <a:srcRect/>
-          <a:stretch>
-            <a:fillRect/>
-          </a:stretch>
-        </a:blipFill>
-        <a:effectLst/>
-      </p:bgPr>
-    </p:bg>
-    <p:spTree>
-      <p:nvGrpSpPr>
-        <p:cNvPr id="1" name=""/>
-        <p:cNvGrpSpPr/>
-        <p:nvPr/>
-      </p:nvGrpSpPr>
-      <p:grpSpPr>
-        <a:xfrm>
-          <a:off x="0" y="0"/>
-          <a:ext cx="0" cy="0"/>
-          <a:chOff x="0" y="0"/>
-          <a:chExt cx="0" cy="0"/>
-        </a:xfrm>
-      </p:grpSpPr>
-      <p:sp>
-        <p:nvSpPr>
-          <p:cNvPr id="2" name="Shape 0"/>
-          <p:cNvSpPr/>
-          <p:nvPr/>
-        </p:nvSpPr>
-        <p:spPr>
-          <a:xfrm>
-            <a:off x="0" y="0"/>
-            <a:ext cx="12191695" cy="6858000"/>
-          </a:xfrm>
-          <a:prstGeom prst="rect">
-            <a:avLst/>
-          </a:prstGeom>
-          <a:solidFill>
-            <a:srgbClr val="08120D">
-              <a:alpha val="70000"/>
-            </a:srgbClr>
-          </a:solidFill>
-          <a:ln/>
-        </p:spPr>
-      </p:sp>
-      <p:sp>
-        <p:nvSpPr>
-          <p:cNvPr id="3" name="Shape 1"/>
-          <p:cNvSpPr/>
-          <p:nvPr/>
-        </p:nvSpPr>
-        <p:spPr>
-          <a:xfrm>
-            <a:off x="0" y="0"/>
-            <a:ext cx="6949440" cy="6858000"/>
-          </a:xfrm>
-          <a:prstGeom prst="rect">
-            <a:avLst/>
-          </a:prstGeom>
-          <a:solidFill>
-            <a:srgbClr val="08120D">
-              <a:alpha val="80000"/>
-            </a:srgbClr>
-          </a:solidFill>
-          <a:ln/>
-        </p:spPr>
-      </p:sp>
-      <p:sp>
-        <p:nvSpPr>
-          <p:cNvPr id="4" name="Text 2"/>
-          <p:cNvSpPr/>
-          <p:nvPr/>
-        </p:nvSpPr>
-        <p:spPr>
-          <a:xfrm>
-            <a:off x="566928" y="1554480"/>
-            <a:ext cx="8229600" cy="292608"/>
-          </a:xfrm>
-          <a:prstGeom prst="rect">
-            <a:avLst/>
-          </a:prstGeom>
-          <a:noFill/>
-          <a:ln/>
-        </p:spPr>
-        <p:txBody>
-          <a:bodyPr wrap="square" lIns="0" tIns="0" rIns="0" bIns="0" rtlCol="0" anchor="ctr"/>
-          <a:lstStyle/>
-          <a:p>
-            <a:pPr algn="l" indent="0" marL="0">
-              <a:buNone/>
-            </a:pPr>
-            <a:r>
-              <a:rPr lang="en-US" sz="1250" b="1" spc="240" kern="0" dirty="0">
-                <a:solidFill>
-                  <a:srgbClr val="9BC53D"/>
-                </a:solidFill>
-                <a:latin typeface="Calibri" pitchFamily="34" charset="0"/>
-                <a:ea typeface="Calibri" pitchFamily="34" charset="-122"/>
-                <a:cs typeface="Calibri" pitchFamily="34" charset="-120"/>
-              </a:rPr>
-              <a:t>OUR PHILOSOPHY · 농민의 세상은 무궁무진합니다</a:t>
-            </a:r>
-            <a:endParaRPr lang="en-US" sz="1250" dirty="0"/>
-          </a:p>
-        </p:txBody>
-      </p:sp>
-      <p:sp>
-        <p:nvSpPr>
-          <p:cNvPr id="5" name="Text 3"/>
-          <p:cNvSpPr/>
-          <p:nvPr/>
-        </p:nvSpPr>
-        <p:spPr>
-          <a:xfrm>
-            <a:off x="566928" y="2103120"/>
-            <a:ext cx="7589520" cy="1737360"/>
-          </a:xfrm>
-          <a:prstGeom prst="rect">
-            <a:avLst/>
-          </a:prstGeom>
-          <a:noFill/>
-          <a:ln/>
-        </p:spPr>
-        <p:txBody>
-          <a:bodyPr wrap="square" lIns="0" tIns="0" rIns="0" bIns="0" rtlCol="0" anchor="ctr"/>
-          <a:lstStyle/>
-          <a:p>
-            <a:pPr indent="0" marL="0">
-              <a:lnSpc>
-                <a:spcPct val="105000"/>
-              </a:lnSpc>
-              <a:buNone/>
-            </a:pPr>
-            <a:r>
-              <a:rPr lang="en-US" sz="3700" b="1" dirty="0">
-                <a:solidFill>
-                  <a:srgbClr val="FFFFFF"/>
-                </a:solidFill>
-                <a:latin typeface="Cambria" pitchFamily="34" charset="0"/>
-                <a:ea typeface="Cambria" pitchFamily="34" charset="-122"/>
-                <a:cs typeface="Cambria" pitchFamily="34" charset="-120"/>
-              </a:rPr>
-              <a:t>"The farmer holds the key to</a:t>
-            </a:r>
-            <a:endParaRPr lang="en-US" sz="3700" dirty="0"/>
-          </a:p>
-          <a:p>
-            <a:pPr indent="0" marL="0">
-              <a:lnSpc>
-                <a:spcPct val="105000"/>
-              </a:lnSpc>
-              <a:buNone/>
-            </a:pPr>
-            <a:r>
-              <a:rPr lang="en-US" sz="3700" b="1" dirty="0">
-                <a:solidFill>
-                  <a:srgbClr val="FFFFFF"/>
-                </a:solidFill>
-                <a:latin typeface="Cambria" pitchFamily="34" charset="0"/>
-                <a:ea typeface="Cambria" pitchFamily="34" charset="-122"/>
-                <a:cs typeface="Cambria" pitchFamily="34" charset="-120"/>
-              </a:rPr>
-              <a:t>humanity's eternal life vault."</a:t>
-            </a:r>
-            <a:endParaRPr lang="en-US" sz="3700" dirty="0"/>
-          </a:p>
-        </p:txBody>
-      </p:sp>
-      <p:sp>
-        <p:nvSpPr>
-          <p:cNvPr id="6" name="Text 4"/>
-          <p:cNvSpPr/>
-          <p:nvPr/>
-        </p:nvSpPr>
-        <p:spPr>
-          <a:xfrm>
-            <a:off x="566928" y="3931920"/>
-            <a:ext cx="7315200" cy="365760"/>
-          </a:xfrm>
-          <a:prstGeom prst="rect">
-            <a:avLst/>
-          </a:prstGeom>
-          <a:noFill/>
-          <a:ln/>
-        </p:spPr>
-        <p:txBody>
-          <a:bodyPr wrap="square" lIns="0" tIns="0" rIns="0" bIns="0" rtlCol="0" anchor="ctr"/>
-          <a:lstStyle/>
-          <a:p>
-            <a:pPr indent="0" marL="0">
-              <a:buNone/>
-            </a:pPr>
-            <a:r>
-              <a:rPr lang="en-US" sz="1500" i="1" dirty="0">
-                <a:solidFill>
-                  <a:srgbClr val="C9D3C4"/>
-                </a:solidFill>
-                <a:latin typeface="Calibri" pitchFamily="34" charset="0"/>
-                <a:ea typeface="Calibri" pitchFamily="34" charset="-122"/>
-                <a:cs typeface="Calibri" pitchFamily="34" charset="-120"/>
-              </a:rPr>
-              <a:t>— Yun Bong-gil, </a:t>
-            </a:r>
-            <a:pPr indent="0" marL="0">
-              <a:buNone/>
-            </a:pPr>
-            <a:r>
-              <a:rPr lang="en-US" sz="1500" dirty="0">
-                <a:solidFill>
-                  <a:srgbClr val="C9D3C4"/>
-                </a:solidFill>
-                <a:latin typeface="Calibri" pitchFamily="34" charset="0"/>
-                <a:ea typeface="Calibri" pitchFamily="34" charset="-122"/>
-                <a:cs typeface="Calibri" pitchFamily="34" charset="-120"/>
-              </a:rPr>
-              <a:t>The Farmer's Reader</a:t>
-            </a:r>
-            <a:pPr indent="0" marL="0">
-              <a:buNone/>
-            </a:pPr>
-            <a:r>
-              <a:rPr lang="en-US" sz="1500" i="1" dirty="0">
-                <a:solidFill>
-                  <a:srgbClr val="C9D3C4"/>
-                </a:solidFill>
-                <a:latin typeface="Calibri" pitchFamily="34" charset="0"/>
-                <a:ea typeface="Calibri" pitchFamily="34" charset="-122"/>
-                <a:cs typeface="Calibri" pitchFamily="34" charset="-120"/>
-              </a:rPr>
-              <a:t>, 1927</a:t>
-            </a:r>
-            <a:endParaRPr lang="en-US" sz="1500" dirty="0"/>
-          </a:p>
-        </p:txBody>
-      </p:sp>
-      <p:sp>
-        <p:nvSpPr>
-          <p:cNvPr id="7" name="Shape 5"/>
-          <p:cNvSpPr/>
-          <p:nvPr/>
-        </p:nvSpPr>
-        <p:spPr>
-          <a:xfrm>
-            <a:off x="566928" y="4663440"/>
-            <a:ext cx="745236" cy="384048"/>
-          </a:xfrm>
-          <a:prstGeom prst="roundRect">
-            <a:avLst>
-              <a:gd name="adj" fmla="val 50000"/>
-            </a:avLst>
-          </a:prstGeom>
-          <a:ln w="19050">
-            <a:solidFill>
-              <a:srgbClr val="9BC53D"/>
-            </a:solidFill>
-            <a:prstDash val="solid"/>
-          </a:ln>
-        </p:spPr>
-      </p:sp>
-      <p:sp>
-        <p:nvSpPr>
-          <p:cNvPr id="8" name="Text 6"/>
-          <p:cNvSpPr/>
-          <p:nvPr/>
-        </p:nvSpPr>
-        <p:spPr>
-          <a:xfrm>
-            <a:off x="566928" y="4663440"/>
-            <a:ext cx="745236" cy="384048"/>
-          </a:xfrm>
-          <a:prstGeom prst="rect">
-            <a:avLst/>
-          </a:prstGeom>
-          <a:noFill/>
-          <a:ln/>
-        </p:spPr>
-        <p:txBody>
-          <a:bodyPr wrap="square" lIns="0" tIns="0" rIns="0" bIns="0" rtlCol="0" anchor="ctr"/>
-          <a:lstStyle/>
-          <a:p>
-            <a:pPr algn="ctr" indent="0" marL="0">
-              <a:buNone/>
-            </a:pPr>
-            <a:r>
-              <a:rPr lang="en-US" sz="1300" b="1" dirty="0">
-                <a:solidFill>
-                  <a:srgbClr val="9BC53D"/>
-                </a:solidFill>
-                <a:latin typeface="Calibri" pitchFamily="34" charset="0"/>
-                <a:ea typeface="Calibri" pitchFamily="34" charset="-122"/>
-                <a:cs typeface="Calibri" pitchFamily="34" charset="-120"/>
-              </a:rPr>
-              <a:t>건강한 흙</a:t>
-            </a:r>
-            <a:endParaRPr lang="en-US" sz="1300" dirty="0"/>
-          </a:p>
-        </p:txBody>
-      </p:sp>
-      <p:sp>
-        <p:nvSpPr>
-          <p:cNvPr id="9" name="Text 7"/>
-          <p:cNvSpPr/>
-          <p:nvPr/>
-        </p:nvSpPr>
-        <p:spPr>
-          <a:xfrm>
-            <a:off x="1403604" y="4663440"/>
-            <a:ext cx="365760" cy="384048"/>
-          </a:xfrm>
-          <a:prstGeom prst="rect">
-            <a:avLst/>
-          </a:prstGeom>
-          <a:noFill/>
-          <a:ln/>
-        </p:spPr>
-        <p:txBody>
-          <a:bodyPr wrap="square" lIns="0" tIns="0" rIns="0" bIns="0" rtlCol="0" anchor="ctr"/>
-          <a:lstStyle/>
-          <a:p>
-            <a:pPr algn="ctr" indent="0" marL="0">
-              <a:buNone/>
-            </a:pPr>
-            <a:r>
-              <a:rPr lang="en-US" sz="1600" dirty="0">
-                <a:solidFill>
-                  <a:srgbClr val="C9D3C4"/>
-                </a:solidFill>
-              </a:rPr>
-              <a:t>→</a:t>
-            </a:r>
-            <a:endParaRPr lang="en-US" sz="1600" dirty="0"/>
-          </a:p>
-        </p:txBody>
-      </p:sp>
-      <p:sp>
-        <p:nvSpPr>
-          <p:cNvPr id="10" name="Shape 8"/>
-          <p:cNvSpPr/>
-          <p:nvPr/>
-        </p:nvSpPr>
-        <p:spPr>
-          <a:xfrm>
-            <a:off x="1815084" y="4663440"/>
-            <a:ext cx="745236" cy="384048"/>
-          </a:xfrm>
-          <a:prstGeom prst="roundRect">
-            <a:avLst>
-              <a:gd name="adj" fmla="val 50000"/>
-            </a:avLst>
-          </a:prstGeom>
-          <a:ln w="19050">
-            <a:solidFill>
-              <a:srgbClr val="9BC53D"/>
-            </a:solidFill>
-            <a:prstDash val="solid"/>
-          </a:ln>
-        </p:spPr>
-      </p:sp>
-      <p:sp>
-        <p:nvSpPr>
-          <p:cNvPr id="11" name="Text 9"/>
-          <p:cNvSpPr/>
-          <p:nvPr/>
-        </p:nvSpPr>
-        <p:spPr>
-          <a:xfrm>
-            <a:off x="1815084" y="4663440"/>
-            <a:ext cx="745236" cy="384048"/>
-          </a:xfrm>
-          <a:prstGeom prst="rect">
-            <a:avLst/>
-          </a:prstGeom>
-          <a:noFill/>
-          <a:ln/>
-        </p:spPr>
-        <p:txBody>
-          <a:bodyPr wrap="square" lIns="0" tIns="0" rIns="0" bIns="0" rtlCol="0" anchor="ctr"/>
-          <a:lstStyle/>
-          <a:p>
-            <a:pPr algn="ctr" indent="0" marL="0">
-              <a:buNone/>
-            </a:pPr>
-            <a:r>
-              <a:rPr lang="en-US" sz="1300" b="1" dirty="0">
-                <a:solidFill>
-                  <a:srgbClr val="9BC53D"/>
-                </a:solidFill>
-                <a:latin typeface="Calibri" pitchFamily="34" charset="0"/>
-                <a:ea typeface="Calibri" pitchFamily="34" charset="-122"/>
-                <a:cs typeface="Calibri" pitchFamily="34" charset="-120"/>
-              </a:rPr>
-              <a:t>행복한 소</a:t>
-            </a:r>
-            <a:endParaRPr lang="en-US" sz="1300" dirty="0"/>
-          </a:p>
-        </p:txBody>
-      </p:sp>
-      <p:sp>
-        <p:nvSpPr>
-          <p:cNvPr id="12" name="Text 10"/>
-          <p:cNvSpPr/>
-          <p:nvPr/>
-        </p:nvSpPr>
-        <p:spPr>
-          <a:xfrm>
-            <a:off x="2651760" y="4663440"/>
-            <a:ext cx="365760" cy="384048"/>
-          </a:xfrm>
-          <a:prstGeom prst="rect">
-            <a:avLst/>
-          </a:prstGeom>
-          <a:noFill/>
-          <a:ln/>
-        </p:spPr>
-        <p:txBody>
-          <a:bodyPr wrap="square" lIns="0" tIns="0" rIns="0" bIns="0" rtlCol="0" anchor="ctr"/>
-          <a:lstStyle/>
-          <a:p>
-            <a:pPr algn="ctr" indent="0" marL="0">
-              <a:buNone/>
-            </a:pPr>
-            <a:r>
-              <a:rPr lang="en-US" sz="1600" dirty="0">
-                <a:solidFill>
-                  <a:srgbClr val="C9D3C4"/>
-                </a:solidFill>
-              </a:rPr>
-              <a:t>→</a:t>
-            </a:r>
-            <a:endParaRPr lang="en-US" sz="1600" dirty="0"/>
-          </a:p>
-        </p:txBody>
-      </p:sp>
-      <p:sp>
-        <p:nvSpPr>
-          <p:cNvPr id="13" name="Shape 11"/>
-          <p:cNvSpPr/>
-          <p:nvPr/>
-        </p:nvSpPr>
-        <p:spPr>
-          <a:xfrm>
-            <a:off x="3063240" y="4663440"/>
-            <a:ext cx="745236" cy="384048"/>
-          </a:xfrm>
-          <a:prstGeom prst="roundRect">
-            <a:avLst>
-              <a:gd name="adj" fmla="val 50000"/>
-            </a:avLst>
-          </a:prstGeom>
-          <a:ln w="19050">
-            <a:solidFill>
-              <a:srgbClr val="9BC53D"/>
-            </a:solidFill>
-            <a:prstDash val="solid"/>
-          </a:ln>
-        </p:spPr>
-      </p:sp>
-      <p:sp>
-        <p:nvSpPr>
-          <p:cNvPr id="14" name="Text 12"/>
-          <p:cNvSpPr/>
-          <p:nvPr/>
-        </p:nvSpPr>
-        <p:spPr>
-          <a:xfrm>
-            <a:off x="3063240" y="4663440"/>
-            <a:ext cx="745236" cy="384048"/>
-          </a:xfrm>
-          <a:prstGeom prst="rect">
-            <a:avLst/>
-          </a:prstGeom>
-          <a:noFill/>
-          <a:ln/>
-        </p:spPr>
-        <p:txBody>
-          <a:bodyPr wrap="square" lIns="0" tIns="0" rIns="0" bIns="0" rtlCol="0" anchor="ctr"/>
-          <a:lstStyle/>
-          <a:p>
-            <a:pPr algn="ctr" indent="0" marL="0">
-              <a:buNone/>
-            </a:pPr>
-            <a:r>
-              <a:rPr lang="en-US" sz="1300" b="1" dirty="0">
-                <a:solidFill>
-                  <a:srgbClr val="9BC53D"/>
-                </a:solidFill>
-                <a:latin typeface="Calibri" pitchFamily="34" charset="0"/>
-                <a:ea typeface="Calibri" pitchFamily="34" charset="-122"/>
-                <a:cs typeface="Calibri" pitchFamily="34" charset="-120"/>
-              </a:rPr>
-              <a:t>좋은 우유</a:t>
-            </a:r>
-            <a:endParaRPr lang="en-US" sz="1300" dirty="0"/>
-          </a:p>
-        </p:txBody>
-      </p:sp>
-      <p:sp>
-        <p:nvSpPr>
-          <p:cNvPr id="15" name="Text 13"/>
-          <p:cNvSpPr/>
-          <p:nvPr/>
-        </p:nvSpPr>
-        <p:spPr>
-          <a:xfrm>
-            <a:off x="4037076" y="4663440"/>
-            <a:ext cx="2194560" cy="384048"/>
-          </a:xfrm>
-          <a:prstGeom prst="rect">
-            <a:avLst/>
-          </a:prstGeom>
-          <a:noFill/>
-          <a:ln/>
-        </p:spPr>
-        <p:txBody>
-          <a:bodyPr wrap="square" lIns="0" tIns="0" rIns="0" bIns="0" rtlCol="0" anchor="ctr"/>
-          <a:lstStyle/>
-          <a:p>
-            <a:pPr indent="0" marL="0">
-              <a:buNone/>
-            </a:pPr>
-            <a:r>
-              <a:rPr lang="en-US" sz="1500" b="1" dirty="0">
-                <a:solidFill>
-                  <a:srgbClr val="DDE6D6"/>
-                </a:solidFill>
-                <a:latin typeface="Calibri" pitchFamily="34" charset="0"/>
-                <a:ea typeface="Calibri" pitchFamily="34" charset="-122"/>
-                <a:cs typeface="Calibri" pitchFamily="34" charset="-120"/>
-              </a:rPr>
-              <a:t>Soil to Soul</a:t>
-            </a:r>
-            <a:endParaRPr lang="en-US" sz="1500" dirty="0"/>
-          </a:p>
-        </p:txBody>
-      </p:sp>
-      <p:sp>
-        <p:nvSpPr>
-          <p:cNvPr id="16" name="Text 14"/>
           <p:cNvSpPr/>
           <p:nvPr/>
         </p:nvSpPr>
@@ -12024,6 +12839,596 @@
   <p:cSld name="Slide 20">
     <p:bg>
       <p:bgPr>
+        <a:blipFill dpi="0" rotWithShape="1">
+          <a:blip r:embed="rId1">
+            <a:lum/>
+          </a:blip>
+          <a:srcRect/>
+          <a:stretch>
+            <a:fillRect/>
+          </a:stretch>
+        </a:blipFill>
+        <a:effectLst/>
+      </p:bgPr>
+    </p:bg>
+    <p:spTree>
+      <p:nvGrpSpPr>
+        <p:cNvPr id="1" name=""/>
+        <p:cNvGrpSpPr/>
+        <p:nvPr/>
+      </p:nvGrpSpPr>
+      <p:grpSpPr>
+        <a:xfrm>
+          <a:off x="0" y="0"/>
+          <a:ext cx="0" cy="0"/>
+          <a:chOff x="0" y="0"/>
+          <a:chExt cx="0" cy="0"/>
+        </a:xfrm>
+      </p:grpSpPr>
+      <p:sp>
+        <p:nvSpPr>
+          <p:cNvPr id="2" name="Shape 0"/>
+          <p:cNvSpPr/>
+          <p:nvPr/>
+        </p:nvSpPr>
+        <p:spPr>
+          <a:xfrm>
+            <a:off x="0" y="0"/>
+            <a:ext cx="12191695" cy="6858000"/>
+          </a:xfrm>
+          <a:prstGeom prst="rect">
+            <a:avLst/>
+          </a:prstGeom>
+          <a:solidFill>
+            <a:srgbClr val="08120D">
+              <a:alpha val="70000"/>
+            </a:srgbClr>
+          </a:solidFill>
+          <a:ln/>
+        </p:spPr>
+      </p:sp>
+      <p:sp>
+        <p:nvSpPr>
+          <p:cNvPr id="3" name="Shape 1"/>
+          <p:cNvSpPr/>
+          <p:nvPr/>
+        </p:nvSpPr>
+        <p:spPr>
+          <a:xfrm>
+            <a:off x="0" y="0"/>
+            <a:ext cx="6949440" cy="6858000"/>
+          </a:xfrm>
+          <a:prstGeom prst="rect">
+            <a:avLst/>
+          </a:prstGeom>
+          <a:solidFill>
+            <a:srgbClr val="08120D">
+              <a:alpha val="80000"/>
+            </a:srgbClr>
+          </a:solidFill>
+          <a:ln/>
+        </p:spPr>
+      </p:sp>
+      <p:sp>
+        <p:nvSpPr>
+          <p:cNvPr id="4" name="Text 2"/>
+          <p:cNvSpPr/>
+          <p:nvPr/>
+        </p:nvSpPr>
+        <p:spPr>
+          <a:xfrm>
+            <a:off x="566928" y="1554480"/>
+            <a:ext cx="8229600" cy="292608"/>
+          </a:xfrm>
+          <a:prstGeom prst="rect">
+            <a:avLst/>
+          </a:prstGeom>
+          <a:noFill/>
+          <a:ln/>
+        </p:spPr>
+        <p:txBody>
+          <a:bodyPr wrap="square" lIns="0" tIns="0" rIns="0" bIns="0" rtlCol="0" anchor="ctr"/>
+          <a:lstStyle/>
+          <a:p>
+            <a:pPr algn="l" indent="0" marL="0">
+              <a:buNone/>
+            </a:pPr>
+            <a:r>
+              <a:rPr lang="en-US" sz="1250" b="1" spc="240" kern="0" dirty="0">
+                <a:solidFill>
+                  <a:srgbClr val="9BC53D"/>
+                </a:solidFill>
+                <a:latin typeface="Calibri" pitchFamily="34" charset="0"/>
+                <a:ea typeface="Calibri" pitchFamily="34" charset="-122"/>
+                <a:cs typeface="Calibri" pitchFamily="34" charset="-120"/>
+              </a:rPr>
+              <a:t>OUR PHILOSOPHY · 농민의 세상은 무궁무진합니다</a:t>
+            </a:r>
+            <a:endParaRPr lang="en-US" sz="1250" dirty="0"/>
+          </a:p>
+        </p:txBody>
+      </p:sp>
+      <p:sp>
+        <p:nvSpPr>
+          <p:cNvPr id="5" name="Text 3"/>
+          <p:cNvSpPr/>
+          <p:nvPr/>
+        </p:nvSpPr>
+        <p:spPr>
+          <a:xfrm>
+            <a:off x="566928" y="2103120"/>
+            <a:ext cx="7589520" cy="1737360"/>
+          </a:xfrm>
+          <a:prstGeom prst="rect">
+            <a:avLst/>
+          </a:prstGeom>
+          <a:noFill/>
+          <a:ln/>
+        </p:spPr>
+        <p:txBody>
+          <a:bodyPr wrap="square" lIns="0" tIns="0" rIns="0" bIns="0" rtlCol="0" anchor="ctr"/>
+          <a:lstStyle/>
+          <a:p>
+            <a:pPr indent="0" marL="0">
+              <a:lnSpc>
+                <a:spcPct val="105000"/>
+              </a:lnSpc>
+              <a:buNone/>
+            </a:pPr>
+            <a:r>
+              <a:rPr lang="en-US" sz="3700" b="1" dirty="0">
+                <a:solidFill>
+                  <a:srgbClr val="FFFFFF"/>
+                </a:solidFill>
+                <a:latin typeface="Cambria" pitchFamily="34" charset="0"/>
+                <a:ea typeface="Cambria" pitchFamily="34" charset="-122"/>
+                <a:cs typeface="Cambria" pitchFamily="34" charset="-120"/>
+              </a:rPr>
+              <a:t>"The farmer holds the key to</a:t>
+            </a:r>
+            <a:endParaRPr lang="en-US" sz="3700" dirty="0"/>
+          </a:p>
+          <a:p>
+            <a:pPr indent="0" marL="0">
+              <a:lnSpc>
+                <a:spcPct val="105000"/>
+              </a:lnSpc>
+              <a:buNone/>
+            </a:pPr>
+            <a:r>
+              <a:rPr lang="en-US" sz="3700" b="1" dirty="0">
+                <a:solidFill>
+                  <a:srgbClr val="FFFFFF"/>
+                </a:solidFill>
+                <a:latin typeface="Cambria" pitchFamily="34" charset="0"/>
+                <a:ea typeface="Cambria" pitchFamily="34" charset="-122"/>
+                <a:cs typeface="Cambria" pitchFamily="34" charset="-120"/>
+              </a:rPr>
+              <a:t>humanity's eternal life vault."</a:t>
+            </a:r>
+            <a:endParaRPr lang="en-US" sz="3700" dirty="0"/>
+          </a:p>
+        </p:txBody>
+      </p:sp>
+      <p:sp>
+        <p:nvSpPr>
+          <p:cNvPr id="6" name="Text 4"/>
+          <p:cNvSpPr/>
+          <p:nvPr/>
+        </p:nvSpPr>
+        <p:spPr>
+          <a:xfrm>
+            <a:off x="566928" y="3931920"/>
+            <a:ext cx="7315200" cy="365760"/>
+          </a:xfrm>
+          <a:prstGeom prst="rect">
+            <a:avLst/>
+          </a:prstGeom>
+          <a:noFill/>
+          <a:ln/>
+        </p:spPr>
+        <p:txBody>
+          <a:bodyPr wrap="square" lIns="0" tIns="0" rIns="0" bIns="0" rtlCol="0" anchor="ctr"/>
+          <a:lstStyle/>
+          <a:p>
+            <a:pPr indent="0" marL="0">
+              <a:buNone/>
+            </a:pPr>
+            <a:r>
+              <a:rPr lang="en-US" sz="1500" i="1" dirty="0">
+                <a:solidFill>
+                  <a:srgbClr val="C9D3C4"/>
+                </a:solidFill>
+                <a:latin typeface="Calibri" pitchFamily="34" charset="0"/>
+                <a:ea typeface="Calibri" pitchFamily="34" charset="-122"/>
+                <a:cs typeface="Calibri" pitchFamily="34" charset="-120"/>
+              </a:rPr>
+              <a:t>— Yun Bong-gil, </a:t>
+            </a:r>
+            <a:pPr indent="0" marL="0">
+              <a:buNone/>
+            </a:pPr>
+            <a:r>
+              <a:rPr lang="en-US" sz="1500" dirty="0">
+                <a:solidFill>
+                  <a:srgbClr val="C9D3C4"/>
+                </a:solidFill>
+                <a:latin typeface="Calibri" pitchFamily="34" charset="0"/>
+                <a:ea typeface="Calibri" pitchFamily="34" charset="-122"/>
+                <a:cs typeface="Calibri" pitchFamily="34" charset="-120"/>
+              </a:rPr>
+              <a:t>The Farmer's Reader</a:t>
+            </a:r>
+            <a:pPr indent="0" marL="0">
+              <a:buNone/>
+            </a:pPr>
+            <a:r>
+              <a:rPr lang="en-US" sz="1500" i="1" dirty="0">
+                <a:solidFill>
+                  <a:srgbClr val="C9D3C4"/>
+                </a:solidFill>
+                <a:latin typeface="Calibri" pitchFamily="34" charset="0"/>
+                <a:ea typeface="Calibri" pitchFamily="34" charset="-122"/>
+                <a:cs typeface="Calibri" pitchFamily="34" charset="-120"/>
+              </a:rPr>
+              <a:t>, 1927</a:t>
+            </a:r>
+            <a:endParaRPr lang="en-US" sz="1500" dirty="0"/>
+          </a:p>
+        </p:txBody>
+      </p:sp>
+      <p:sp>
+        <p:nvSpPr>
+          <p:cNvPr id="7" name="Shape 5"/>
+          <p:cNvSpPr/>
+          <p:nvPr/>
+        </p:nvSpPr>
+        <p:spPr>
+          <a:xfrm>
+            <a:off x="566928" y="4663440"/>
+            <a:ext cx="745236" cy="384048"/>
+          </a:xfrm>
+          <a:prstGeom prst="roundRect">
+            <a:avLst>
+              <a:gd name="adj" fmla="val 50000"/>
+            </a:avLst>
+          </a:prstGeom>
+          <a:ln w="19050">
+            <a:solidFill>
+              <a:srgbClr val="9BC53D"/>
+            </a:solidFill>
+            <a:prstDash val="solid"/>
+          </a:ln>
+        </p:spPr>
+      </p:sp>
+      <p:sp>
+        <p:nvSpPr>
+          <p:cNvPr id="8" name="Text 6"/>
+          <p:cNvSpPr/>
+          <p:nvPr/>
+        </p:nvSpPr>
+        <p:spPr>
+          <a:xfrm>
+            <a:off x="566928" y="4663440"/>
+            <a:ext cx="745236" cy="384048"/>
+          </a:xfrm>
+          <a:prstGeom prst="rect">
+            <a:avLst/>
+          </a:prstGeom>
+          <a:noFill/>
+          <a:ln/>
+        </p:spPr>
+        <p:txBody>
+          <a:bodyPr wrap="square" lIns="0" tIns="0" rIns="0" bIns="0" rtlCol="0" anchor="ctr"/>
+          <a:lstStyle/>
+          <a:p>
+            <a:pPr algn="ctr" indent="0" marL="0">
+              <a:buNone/>
+            </a:pPr>
+            <a:r>
+              <a:rPr lang="en-US" sz="1300" b="1" dirty="0">
+                <a:solidFill>
+                  <a:srgbClr val="9BC53D"/>
+                </a:solidFill>
+                <a:latin typeface="Calibri" pitchFamily="34" charset="0"/>
+                <a:ea typeface="Calibri" pitchFamily="34" charset="-122"/>
+                <a:cs typeface="Calibri" pitchFamily="34" charset="-120"/>
+              </a:rPr>
+              <a:t>건강한 흙</a:t>
+            </a:r>
+            <a:endParaRPr lang="en-US" sz="1300" dirty="0"/>
+          </a:p>
+        </p:txBody>
+      </p:sp>
+      <p:sp>
+        <p:nvSpPr>
+          <p:cNvPr id="9" name="Text 7"/>
+          <p:cNvSpPr/>
+          <p:nvPr/>
+        </p:nvSpPr>
+        <p:spPr>
+          <a:xfrm>
+            <a:off x="1403604" y="4663440"/>
+            <a:ext cx="365760" cy="384048"/>
+          </a:xfrm>
+          <a:prstGeom prst="rect">
+            <a:avLst/>
+          </a:prstGeom>
+          <a:noFill/>
+          <a:ln/>
+        </p:spPr>
+        <p:txBody>
+          <a:bodyPr wrap="square" lIns="0" tIns="0" rIns="0" bIns="0" rtlCol="0" anchor="ctr"/>
+          <a:lstStyle/>
+          <a:p>
+            <a:pPr algn="ctr" indent="0" marL="0">
+              <a:buNone/>
+            </a:pPr>
+            <a:r>
+              <a:rPr lang="en-US" sz="1600" dirty="0">
+                <a:solidFill>
+                  <a:srgbClr val="C9D3C4"/>
+                </a:solidFill>
+              </a:rPr>
+              <a:t>→</a:t>
+            </a:r>
+            <a:endParaRPr lang="en-US" sz="1600" dirty="0"/>
+          </a:p>
+        </p:txBody>
+      </p:sp>
+      <p:sp>
+        <p:nvSpPr>
+          <p:cNvPr id="10" name="Shape 8"/>
+          <p:cNvSpPr/>
+          <p:nvPr/>
+        </p:nvSpPr>
+        <p:spPr>
+          <a:xfrm>
+            <a:off x="1815084" y="4663440"/>
+            <a:ext cx="745236" cy="384048"/>
+          </a:xfrm>
+          <a:prstGeom prst="roundRect">
+            <a:avLst>
+              <a:gd name="adj" fmla="val 50000"/>
+            </a:avLst>
+          </a:prstGeom>
+          <a:ln w="19050">
+            <a:solidFill>
+              <a:srgbClr val="9BC53D"/>
+            </a:solidFill>
+            <a:prstDash val="solid"/>
+          </a:ln>
+        </p:spPr>
+      </p:sp>
+      <p:sp>
+        <p:nvSpPr>
+          <p:cNvPr id="11" name="Text 9"/>
+          <p:cNvSpPr/>
+          <p:nvPr/>
+        </p:nvSpPr>
+        <p:spPr>
+          <a:xfrm>
+            <a:off x="1815084" y="4663440"/>
+            <a:ext cx="745236" cy="384048"/>
+          </a:xfrm>
+          <a:prstGeom prst="rect">
+            <a:avLst/>
+          </a:prstGeom>
+          <a:noFill/>
+          <a:ln/>
+        </p:spPr>
+        <p:txBody>
+          <a:bodyPr wrap="square" lIns="0" tIns="0" rIns="0" bIns="0" rtlCol="0" anchor="ctr"/>
+          <a:lstStyle/>
+          <a:p>
+            <a:pPr algn="ctr" indent="0" marL="0">
+              <a:buNone/>
+            </a:pPr>
+            <a:r>
+              <a:rPr lang="en-US" sz="1300" b="1" dirty="0">
+                <a:solidFill>
+                  <a:srgbClr val="9BC53D"/>
+                </a:solidFill>
+                <a:latin typeface="Calibri" pitchFamily="34" charset="0"/>
+                <a:ea typeface="Calibri" pitchFamily="34" charset="-122"/>
+                <a:cs typeface="Calibri" pitchFamily="34" charset="-120"/>
+              </a:rPr>
+              <a:t>행복한 소</a:t>
+            </a:r>
+            <a:endParaRPr lang="en-US" sz="1300" dirty="0"/>
+          </a:p>
+        </p:txBody>
+      </p:sp>
+      <p:sp>
+        <p:nvSpPr>
+          <p:cNvPr id="12" name="Text 10"/>
+          <p:cNvSpPr/>
+          <p:nvPr/>
+        </p:nvSpPr>
+        <p:spPr>
+          <a:xfrm>
+            <a:off x="2651760" y="4663440"/>
+            <a:ext cx="365760" cy="384048"/>
+          </a:xfrm>
+          <a:prstGeom prst="rect">
+            <a:avLst/>
+          </a:prstGeom>
+          <a:noFill/>
+          <a:ln/>
+        </p:spPr>
+        <p:txBody>
+          <a:bodyPr wrap="square" lIns="0" tIns="0" rIns="0" bIns="0" rtlCol="0" anchor="ctr"/>
+          <a:lstStyle/>
+          <a:p>
+            <a:pPr algn="ctr" indent="0" marL="0">
+              <a:buNone/>
+            </a:pPr>
+            <a:r>
+              <a:rPr lang="en-US" sz="1600" dirty="0">
+                <a:solidFill>
+                  <a:srgbClr val="C9D3C4"/>
+                </a:solidFill>
+              </a:rPr>
+              <a:t>→</a:t>
+            </a:r>
+            <a:endParaRPr lang="en-US" sz="1600" dirty="0"/>
+          </a:p>
+        </p:txBody>
+      </p:sp>
+      <p:sp>
+        <p:nvSpPr>
+          <p:cNvPr id="13" name="Shape 11"/>
+          <p:cNvSpPr/>
+          <p:nvPr/>
+        </p:nvSpPr>
+        <p:spPr>
+          <a:xfrm>
+            <a:off x="3063240" y="4663440"/>
+            <a:ext cx="745236" cy="384048"/>
+          </a:xfrm>
+          <a:prstGeom prst="roundRect">
+            <a:avLst>
+              <a:gd name="adj" fmla="val 50000"/>
+            </a:avLst>
+          </a:prstGeom>
+          <a:ln w="19050">
+            <a:solidFill>
+              <a:srgbClr val="9BC53D"/>
+            </a:solidFill>
+            <a:prstDash val="solid"/>
+          </a:ln>
+        </p:spPr>
+      </p:sp>
+      <p:sp>
+        <p:nvSpPr>
+          <p:cNvPr id="14" name="Text 12"/>
+          <p:cNvSpPr/>
+          <p:nvPr/>
+        </p:nvSpPr>
+        <p:spPr>
+          <a:xfrm>
+            <a:off x="3063240" y="4663440"/>
+            <a:ext cx="745236" cy="384048"/>
+          </a:xfrm>
+          <a:prstGeom prst="rect">
+            <a:avLst/>
+          </a:prstGeom>
+          <a:noFill/>
+          <a:ln/>
+        </p:spPr>
+        <p:txBody>
+          <a:bodyPr wrap="square" lIns="0" tIns="0" rIns="0" bIns="0" rtlCol="0" anchor="ctr"/>
+          <a:lstStyle/>
+          <a:p>
+            <a:pPr algn="ctr" indent="0" marL="0">
+              <a:buNone/>
+            </a:pPr>
+            <a:r>
+              <a:rPr lang="en-US" sz="1300" b="1" dirty="0">
+                <a:solidFill>
+                  <a:srgbClr val="9BC53D"/>
+                </a:solidFill>
+                <a:latin typeface="Calibri" pitchFamily="34" charset="0"/>
+                <a:ea typeface="Calibri" pitchFamily="34" charset="-122"/>
+                <a:cs typeface="Calibri" pitchFamily="34" charset="-120"/>
+              </a:rPr>
+              <a:t>좋은 우유</a:t>
+            </a:r>
+            <a:endParaRPr lang="en-US" sz="1300" dirty="0"/>
+          </a:p>
+        </p:txBody>
+      </p:sp>
+      <p:sp>
+        <p:nvSpPr>
+          <p:cNvPr id="15" name="Text 13"/>
+          <p:cNvSpPr/>
+          <p:nvPr/>
+        </p:nvSpPr>
+        <p:spPr>
+          <a:xfrm>
+            <a:off x="4037076" y="4663440"/>
+            <a:ext cx="2194560" cy="384048"/>
+          </a:xfrm>
+          <a:prstGeom prst="rect">
+            <a:avLst/>
+          </a:prstGeom>
+          <a:noFill/>
+          <a:ln/>
+        </p:spPr>
+        <p:txBody>
+          <a:bodyPr wrap="square" lIns="0" tIns="0" rIns="0" bIns="0" rtlCol="0" anchor="ctr"/>
+          <a:lstStyle/>
+          <a:p>
+            <a:pPr indent="0" marL="0">
+              <a:buNone/>
+            </a:pPr>
+            <a:r>
+              <a:rPr lang="en-US" sz="1500" b="1" dirty="0">
+                <a:solidFill>
+                  <a:srgbClr val="DDE6D6"/>
+                </a:solidFill>
+                <a:latin typeface="Calibri" pitchFamily="34" charset="0"/>
+                <a:ea typeface="Calibri" pitchFamily="34" charset="-122"/>
+                <a:cs typeface="Calibri" pitchFamily="34" charset="-120"/>
+              </a:rPr>
+              <a:t>Soil to Soul</a:t>
+            </a:r>
+            <a:endParaRPr lang="en-US" sz="1500" dirty="0"/>
+          </a:p>
+        </p:txBody>
+      </p:sp>
+      <p:sp>
+        <p:nvSpPr>
+          <p:cNvPr id="16" name="Text 14"/>
+          <p:cNvSpPr/>
+          <p:nvPr/>
+        </p:nvSpPr>
+        <p:spPr>
+          <a:xfrm>
+            <a:off x="11002975" y="6400800"/>
+            <a:ext cx="822960" cy="274320"/>
+          </a:xfrm>
+          <a:prstGeom prst="rect">
+            <a:avLst/>
+          </a:prstGeom>
+          <a:noFill/>
+          <a:ln/>
+        </p:spPr>
+        <p:txBody>
+          <a:bodyPr wrap="square" lIns="0" tIns="0" rIns="0" bIns="0" rtlCol="0" anchor="ctr"/>
+          <a:lstStyle/>
+          <a:p>
+            <a:pPr algn="r" indent="0" marL="0">
+              <a:buNone/>
+            </a:pPr>
+            <a:r>
+              <a:rPr lang="en-US" sz="1100" b="1" spc="200" kern="0" dirty="0">
+                <a:solidFill>
+                  <a:srgbClr val="9DA99C"/>
+                </a:solidFill>
+                <a:latin typeface="Calibri" pitchFamily="34" charset="0"/>
+                <a:ea typeface="Calibri" pitchFamily="34" charset="-122"/>
+                <a:cs typeface="Calibri" pitchFamily="34" charset="-120"/>
+              </a:rPr>
+              <a:t>20</a:t>
+            </a:r>
+            <a:endParaRPr lang="en-US" sz="1100" dirty="0"/>
+          </a:p>
+        </p:txBody>
+      </p:sp>
+    </p:spTree>
+  </p:cSld>
+  <p:clrMapOvr>
+    <a:masterClrMapping/>
+  </p:clrMapOvr>
+</p:sld>
+</file>
+
+<file path=ppt/slides/slide21.xml><?xml version="1.0" encoding="utf-8"?>
+<p:sld xmlns:a="http://schemas.openxmlformats.org/drawingml/2006/main" xmlns:r="http://schemas.openxmlformats.org/officeDocument/2006/relationships" xmlns:p="http://schemas.openxmlformats.org/presentationml/2006/main">
+  <p:cSld name="Slide 21">
+    <p:bg>
+      <p:bgPr>
         <a:solidFill>
           <a:srgbClr val="15291F"/>
         </a:solidFill>
@@ -12358,7 +13763,7 @@
                 <a:ea typeface="Calibri" pitchFamily="34" charset="-122"/>
                 <a:cs typeface="Calibri" pitchFamily="34" charset="-120"/>
               </a:rPr>
-              <a:t>20</a:t>
+              <a:t>21</a:t>
             </a:r>
             <a:endParaRPr lang="en-US" sz="1100" dirty="0"/>
           </a:p>
@@ -17513,7 +18918,7 @@
                 <a:ea typeface="Calibri" pitchFamily="34" charset="-122"/>
                 <a:cs typeface="Calibri" pitchFamily="34" charset="-120"/>
               </a:rPr>
-              <a:t>SUSTAINABLE DAIRY · 송영신목장</a:t>
+              <a:t>ECO-FRIENDLY LIVESTOCK · 피트모스 HBP 시스템</a:t>
             </a:r>
             <a:endParaRPr lang="en-US" sz="1250" dirty="0"/>
           </a:p>
@@ -17527,8 +18932,8 @@
         </p:nvSpPr>
         <p:spPr>
           <a:xfrm>
-            <a:off x="566928" y="960120"/>
-            <a:ext cx="7315200" cy="1371600"/>
+            <a:off x="566928" y="932688"/>
+            <a:ext cx="7406640" cy="1005840"/>
           </a:xfrm>
           <a:prstGeom prst="rect">
             <a:avLst/>
@@ -17547,7 +18952,7 @@
               <a:buNone/>
             </a:pPr>
             <a:r>
-              <a:rPr lang="en-US" sz="3600" b="1" dirty="0">
+              <a:rPr lang="en-US" sz="3000" b="1" dirty="0">
                 <a:solidFill>
                   <a:srgbClr val="16221C"/>
                 </a:solidFill>
@@ -17555,9 +18960,9 @@
                 <a:ea typeface="Cambria" pitchFamily="34" charset="-122"/>
                 <a:cs typeface="Cambria" pitchFamily="34" charset="-120"/>
               </a:rPr>
-              <a:t>Song Young Shin Farm</a:t>
-            </a:r>
-            <a:endParaRPr lang="en-US" sz="3600" dirty="0"/>
+              <a:t>HBP — a peat-moss bedding that feeds the soil</a:t>
+            </a:r>
+            <a:endParaRPr lang="en-US" sz="3000" dirty="0"/>
           </a:p>
         </p:txBody>
       </p:sp>
@@ -17569,86 +18974,8 @@
         </p:nvSpPr>
         <p:spPr>
           <a:xfrm>
-            <a:off x="566928" y="1600200"/>
-            <a:ext cx="7315200" cy="365760"/>
-          </a:xfrm>
-          <a:prstGeom prst="rect">
-            <a:avLst/>
-          </a:prstGeom>
-          <a:noFill/>
-          <a:ln/>
-        </p:spPr>
-        <p:txBody>
-          <a:bodyPr wrap="square" lIns="0" tIns="0" rIns="0" bIns="0" rtlCol="0" anchor="ctr"/>
-          <a:lstStyle/>
-          <a:p>
-            <a:pPr indent="0" marL="0">
-              <a:buNone/>
-            </a:pPr>
-            <a:r>
-              <a:rPr lang="en-US" sz="1600" b="1" dirty="0">
-                <a:solidFill>
-                  <a:srgbClr val="4F7D2E"/>
-                </a:solidFill>
-                <a:latin typeface="Calibri" pitchFamily="34" charset="0"/>
-                <a:ea typeface="Calibri" pitchFamily="34" charset="-122"/>
-                <a:cs typeface="Calibri" pitchFamily="34" charset="-120"/>
-              </a:rPr>
-              <a:t>Korea's 1st animal-welfare &amp; low-carbon certified dairy farm</a:t>
-            </a:r>
-            <a:endParaRPr lang="en-US" sz="1600" dirty="0"/>
-          </a:p>
-        </p:txBody>
-      </p:sp>
-      <p:sp>
-        <p:nvSpPr>
-          <p:cNvPr id="5" name="Text 3"/>
-          <p:cNvSpPr/>
-          <p:nvPr/>
-        </p:nvSpPr>
-        <p:spPr>
-          <a:xfrm>
-            <a:off x="566928" y="2286000"/>
-            <a:ext cx="1280160" cy="548640"/>
-          </a:xfrm>
-          <a:prstGeom prst="rect">
-            <a:avLst/>
-          </a:prstGeom>
-          <a:noFill/>
-          <a:ln/>
-        </p:spPr>
-        <p:txBody>
-          <a:bodyPr wrap="square" lIns="0" tIns="0" rIns="0" bIns="0" rtlCol="0" anchor="ctr"/>
-          <a:lstStyle/>
-          <a:p>
-            <a:pPr algn="l" indent="0" marL="0">
-              <a:buNone/>
-            </a:pPr>
-            <a:r>
-              <a:rPr lang="en-US" sz="2600" b="1" dirty="0">
-                <a:solidFill>
-                  <a:srgbClr val="4F7D2E"/>
-                </a:solidFill>
-                <a:latin typeface="Cambria" pitchFamily="34" charset="0"/>
-                <a:ea typeface="Cambria" pitchFamily="34" charset="-122"/>
-                <a:cs typeface="Cambria" pitchFamily="34" charset="-120"/>
-              </a:rPr>
-              <a:t>1st</a:t>
-            </a:r>
-            <a:endParaRPr lang="en-US" sz="2600" dirty="0"/>
-          </a:p>
-        </p:txBody>
-      </p:sp>
-      <p:sp>
-        <p:nvSpPr>
-          <p:cNvPr id="6" name="Text 4"/>
-          <p:cNvSpPr/>
-          <p:nvPr/>
-        </p:nvSpPr>
-        <p:spPr>
-          <a:xfrm>
-            <a:off x="1892808" y="2286000"/>
-            <a:ext cx="2286000" cy="640080"/>
+            <a:off x="566928" y="1783080"/>
+            <a:ext cx="7223760" cy="868680"/>
           </a:xfrm>
           <a:prstGeom prst="rect">
             <a:avLst/>
@@ -17662,32 +18989,29 @@
           <a:p>
             <a:pPr indent="0" marL="0">
               <a:lnSpc>
-                <a:spcPct val="95000"/>
+                <a:spcPct val="108000"/>
               </a:lnSpc>
               <a:buNone/>
             </a:pPr>
             <a:r>
-              <a:rPr lang="en-US" sz="1250" b="1" dirty="0">
-                <a:solidFill>
-                  <a:srgbClr val="39463E"/>
-                </a:solidFill>
-                <a:latin typeface="Calibri" pitchFamily="34" charset="0"/>
-                <a:ea typeface="Calibri" pitchFamily="34" charset="-122"/>
-                <a:cs typeface="Calibri" pitchFamily="34" charset="-120"/>
-              </a:rPr>
-              <a:t>Animal-welfare &amp;</a:t>
-            </a:r>
-            <a:endParaRPr lang="en-US" sz="1250" dirty="0"/>
-          </a:p>
-          <a:p>
+              <a:rPr lang="en-US" sz="1450" b="1" dirty="0">
+                <a:solidFill>
+                  <a:srgbClr val="4F7D2E"/>
+                </a:solidFill>
+                <a:latin typeface="Calibri" pitchFamily="34" charset="0"/>
+                <a:ea typeface="Calibri" pitchFamily="34" charset="-122"/>
+                <a:cs typeface="Calibri" pitchFamily="34" charset="-120"/>
+              </a:rPr>
+              <a:t>The HBP system </a:t>
+            </a:r>
             <a:pPr indent="0" marL="0">
               <a:lnSpc>
-                <a:spcPct val="95000"/>
+                <a:spcPct val="108000"/>
               </a:lnSpc>
               <a:buNone/>
             </a:pPr>
             <a:r>
-              <a:rPr lang="en-US" sz="1250" b="1" dirty="0">
+              <a:rPr lang="en-US" sz="1450" dirty="0">
                 <a:solidFill>
                   <a:srgbClr val="39463E"/>
                 </a:solidFill>
@@ -17695,9 +19019,82 @@
                 <a:ea typeface="Calibri" pitchFamily="34" charset="-122"/>
                 <a:cs typeface="Calibri" pitchFamily="34" charset="-120"/>
               </a:rPr>
-              <a:t>low-carbon certified</a:t>
-            </a:r>
-            <a:endParaRPr lang="en-US" sz="1250" dirty="0"/>
+              <a:t>makes the barn floor the first step of the nutrient loop. A peat-moss bedding absorbs moisture and odour, keeps cows dry and healthy, then composts quickly into organic fertiliser for the grassland — closing the D2O circle.</a:t>
+            </a:r>
+            <a:endParaRPr lang="en-US" sz="1450" dirty="0"/>
+          </a:p>
+        </p:txBody>
+      </p:sp>
+      <p:sp>
+        <p:nvSpPr>
+          <p:cNvPr id="5" name="Shape 3"/>
+          <p:cNvSpPr/>
+          <p:nvPr/>
+        </p:nvSpPr>
+        <p:spPr>
+          <a:xfrm>
+            <a:off x="566928" y="2761488"/>
+            <a:ext cx="3502152" cy="1280160"/>
+          </a:xfrm>
+          <a:prstGeom prst="roundRect">
+            <a:avLst>
+              <a:gd name="adj" fmla="val 7857"/>
+            </a:avLst>
+          </a:prstGeom>
+          <a:solidFill>
+            <a:srgbClr val="FFFFFF"/>
+          </a:solidFill>
+          <a:ln w="12700">
+            <a:solidFill>
+              <a:srgbClr val="E4E0D2"/>
+            </a:solidFill>
+            <a:prstDash val="solid"/>
+          </a:ln>
+          <a:effectLst>
+            <a:outerShdw sx="100000" sy="100000" kx="0" ky="0" algn="bl" rotWithShape="0" blurRad="88900" dist="25400" dir="5400000">
+              <a:srgbClr val="0B140F">
+                <a:alpha val="16000"/>
+              </a:srgbClr>
+            </a:outerShdw>
+          </a:effectLst>
+        </p:spPr>
+      </p:sp>
+      <p:sp>
+        <p:nvSpPr>
+          <p:cNvPr id="6" name="Text 4"/>
+          <p:cNvSpPr/>
+          <p:nvPr/>
+        </p:nvSpPr>
+        <p:spPr>
+          <a:xfrm>
+            <a:off x="768096" y="2907792"/>
+            <a:ext cx="3136392" cy="320040"/>
+          </a:xfrm>
+          <a:prstGeom prst="rect">
+            <a:avLst/>
+          </a:prstGeom>
+          <a:noFill/>
+          <a:ln/>
+        </p:spPr>
+        <p:txBody>
+          <a:bodyPr wrap="square" lIns="0" tIns="0" rIns="0" bIns="0" rtlCol="0" anchor="ctr"/>
+          <a:lstStyle/>
+          <a:p>
+            <a:pPr indent="0" marL="0">
+              <a:buNone/>
+            </a:pPr>
+            <a:r>
+              <a:rPr lang="en-US" sz="1500" b="1" dirty="0">
+                <a:solidFill>
+                  <a:srgbClr val="9A6B3A"/>
+                </a:solidFill>
+                <a:latin typeface="Calibri" pitchFamily="34" charset="0"/>
+                <a:ea typeface="Calibri" pitchFamily="34" charset="-122"/>
+                <a:cs typeface="Calibri" pitchFamily="34" charset="-120"/>
+              </a:rPr>
+              <a:t>💧 High absorption</a:t>
+            </a:r>
+            <a:endParaRPr lang="en-US" sz="1500" dirty="0"/>
           </a:p>
         </p:txBody>
       </p:sp>
@@ -17709,47 +19106,8 @@
         </p:nvSpPr>
         <p:spPr>
           <a:xfrm>
-            <a:off x="566928" y="3246120"/>
-            <a:ext cx="1280160" cy="548640"/>
-          </a:xfrm>
-          <a:prstGeom prst="rect">
-            <a:avLst/>
-          </a:prstGeom>
-          <a:noFill/>
-          <a:ln/>
-        </p:spPr>
-        <p:txBody>
-          <a:bodyPr wrap="square" lIns="0" tIns="0" rIns="0" bIns="0" rtlCol="0" anchor="ctr"/>
-          <a:lstStyle/>
-          <a:p>
-            <a:pPr algn="l" indent="0" marL="0">
-              <a:buNone/>
-            </a:pPr>
-            <a:r>
-              <a:rPr lang="en-US" sz="2600" b="1" dirty="0">
-                <a:solidFill>
-                  <a:srgbClr val="9A6B3A"/>
-                </a:solidFill>
-                <a:latin typeface="Cambria" pitchFamily="34" charset="0"/>
-                <a:ea typeface="Cambria" pitchFamily="34" charset="-122"/>
-                <a:cs typeface="Cambria" pitchFamily="34" charset="-120"/>
-              </a:rPr>
-              <a:t>30ha</a:t>
-            </a:r>
-            <a:endParaRPr lang="en-US" sz="2600" dirty="0"/>
-          </a:p>
-        </p:txBody>
-      </p:sp>
-      <p:sp>
-        <p:nvSpPr>
-          <p:cNvPr id="8" name="Text 6"/>
-          <p:cNvSpPr/>
-          <p:nvPr/>
-        </p:nvSpPr>
-        <p:spPr>
-          <a:xfrm>
-            <a:off x="1892808" y="3246120"/>
-            <a:ext cx="2286000" cy="640080"/>
+            <a:off x="768096" y="3264408"/>
+            <a:ext cx="3136392" cy="685800"/>
           </a:xfrm>
           <a:prstGeom prst="rect">
             <a:avLst/>
@@ -17763,12 +19121,12 @@
           <a:p>
             <a:pPr indent="0" marL="0">
               <a:lnSpc>
-                <a:spcPct val="95000"/>
+                <a:spcPct val="103000"/>
               </a:lnSpc>
               <a:buNone/>
             </a:pPr>
             <a:r>
-              <a:rPr lang="en-US" sz="1250" b="1" dirty="0">
+              <a:rPr lang="en-US" sz="1250" dirty="0">
                 <a:solidFill>
                   <a:srgbClr val="39463E"/>
                 </a:solidFill>
@@ -17776,19 +19134,114 @@
                 <a:ea typeface="Calibri" pitchFamily="34" charset="-122"/>
                 <a:cs typeface="Calibri" pitchFamily="34" charset="-120"/>
               </a:rPr>
-              <a:t>Own grassland for</a:t>
+              <a:t>Peat moss locks in moisture &amp; ammonia — a dry floor, far less odour.</a:t>
             </a:r>
             <a:endParaRPr lang="en-US" sz="1250" dirty="0"/>
           </a:p>
+        </p:txBody>
+      </p:sp>
+      <p:sp>
+        <p:nvSpPr>
+          <p:cNvPr id="8" name="Shape 6"/>
+          <p:cNvSpPr/>
+          <p:nvPr/>
+        </p:nvSpPr>
+        <p:spPr>
+          <a:xfrm>
+            <a:off x="4251960" y="2761488"/>
+            <a:ext cx="3502152" cy="1280160"/>
+          </a:xfrm>
+          <a:prstGeom prst="roundRect">
+            <a:avLst>
+              <a:gd name="adj" fmla="val 7857"/>
+            </a:avLst>
+          </a:prstGeom>
+          <a:solidFill>
+            <a:srgbClr val="FFFFFF"/>
+          </a:solidFill>
+          <a:ln w="12700">
+            <a:solidFill>
+              <a:srgbClr val="E4E0D2"/>
+            </a:solidFill>
+            <a:prstDash val="solid"/>
+          </a:ln>
+          <a:effectLst>
+            <a:outerShdw sx="100000" sy="100000" kx="0" ky="0" algn="bl" rotWithShape="0" blurRad="88900" dist="25400" dir="5400000">
+              <a:srgbClr val="0B140F">
+                <a:alpha val="16000"/>
+              </a:srgbClr>
+            </a:outerShdw>
+          </a:effectLst>
+        </p:spPr>
+      </p:sp>
+      <p:sp>
+        <p:nvSpPr>
+          <p:cNvPr id="9" name="Text 7"/>
+          <p:cNvSpPr/>
+          <p:nvPr/>
+        </p:nvSpPr>
+        <p:spPr>
+          <a:xfrm>
+            <a:off x="4453128" y="2907792"/>
+            <a:ext cx="3136392" cy="320040"/>
+          </a:xfrm>
+          <a:prstGeom prst="rect">
+            <a:avLst/>
+          </a:prstGeom>
+          <a:noFill/>
+          <a:ln/>
+        </p:spPr>
+        <p:txBody>
+          <a:bodyPr wrap="square" lIns="0" tIns="0" rIns="0" bIns="0" rtlCol="0" anchor="ctr"/>
+          <a:lstStyle/>
+          <a:p>
+            <a:pPr indent="0" marL="0">
+              <a:buNone/>
+            </a:pPr>
+            <a:r>
+              <a:rPr lang="en-US" sz="1500" b="1" dirty="0">
+                <a:solidFill>
+                  <a:srgbClr val="4F7D2E"/>
+                </a:solidFill>
+                <a:latin typeface="Calibri" pitchFamily="34" charset="0"/>
+                <a:ea typeface="Calibri" pitchFamily="34" charset="-122"/>
+                <a:cs typeface="Calibri" pitchFamily="34" charset="-120"/>
+              </a:rPr>
+              <a:t>🐄 Animal welfare</a:t>
+            </a:r>
+            <a:endParaRPr lang="en-US" sz="1500" dirty="0"/>
+          </a:p>
+        </p:txBody>
+      </p:sp>
+      <p:sp>
+        <p:nvSpPr>
+          <p:cNvPr id="10" name="Text 8"/>
+          <p:cNvSpPr/>
+          <p:nvPr/>
+        </p:nvSpPr>
+        <p:spPr>
+          <a:xfrm>
+            <a:off x="4453128" y="3264408"/>
+            <a:ext cx="3136392" cy="685800"/>
+          </a:xfrm>
+          <a:prstGeom prst="rect">
+            <a:avLst/>
+          </a:prstGeom>
+          <a:noFill/>
+          <a:ln/>
+        </p:spPr>
+        <p:txBody>
+          <a:bodyPr wrap="square" lIns="0" tIns="0" rIns="0" bIns="0" rtlCol="0" anchor="ctr"/>
+          <a:lstStyle/>
           <a:p>
             <a:pPr indent="0" marL="0">
               <a:lnSpc>
-                <a:spcPct val="95000"/>
+                <a:spcPct val="103000"/>
               </a:lnSpc>
               <a:buNone/>
             </a:pPr>
             <a:r>
-              <a:rPr lang="en-US" sz="1250" b="1" dirty="0">
+              <a:rPr lang="en-US" sz="1250" dirty="0">
                 <a:solidFill>
                   <a:srgbClr val="39463E"/>
                 </a:solidFill>
@@ -17796,7 +19249,7 @@
                 <a:ea typeface="Calibri" pitchFamily="34" charset="-122"/>
                 <a:cs typeface="Calibri" pitchFamily="34" charset="-120"/>
               </a:rPr>
-              <a:t>home-grown feed</a:t>
+              <a:t>Soft, dry bedding → cleaner udders, healthier hooves &amp; skin.</a:t>
             </a:r>
             <a:endParaRPr lang="en-US" sz="1250" dirty="0"/>
           </a:p>
@@ -17804,53 +19257,87 @@
       </p:sp>
       <p:sp>
         <p:nvSpPr>
-          <p:cNvPr id="9" name="Text 7"/>
+          <p:cNvPr id="11" name="Shape 9"/>
           <p:cNvSpPr/>
           <p:nvPr/>
         </p:nvSpPr>
         <p:spPr>
           <a:xfrm>
             <a:off x="566928" y="4206240"/>
-            <a:ext cx="1280160" cy="548640"/>
-          </a:xfrm>
-          <a:prstGeom prst="rect">
-            <a:avLst/>
-          </a:prstGeom>
-          <a:noFill/>
-          <a:ln/>
-        </p:spPr>
-        <p:txBody>
-          <a:bodyPr wrap="square" lIns="0" tIns="0" rIns="0" bIns="0" rtlCol="0" anchor="ctr"/>
-          <a:lstStyle/>
-          <a:p>
-            <a:pPr algn="l" indent="0" marL="0">
-              <a:buNone/>
-            </a:pPr>
-            <a:r>
-              <a:rPr lang="en-US" sz="3000" b="1" dirty="0">
+            <a:ext cx="3502152" cy="1280160"/>
+          </a:xfrm>
+          <a:prstGeom prst="roundRect">
+            <a:avLst>
+              <a:gd name="adj" fmla="val 7857"/>
+            </a:avLst>
+          </a:prstGeom>
+          <a:solidFill>
+            <a:srgbClr val="FFFFFF"/>
+          </a:solidFill>
+          <a:ln w="12700">
+            <a:solidFill>
+              <a:srgbClr val="E4E0D2"/>
+            </a:solidFill>
+            <a:prstDash val="solid"/>
+          </a:ln>
+          <a:effectLst>
+            <a:outerShdw sx="100000" sy="100000" kx="0" ky="0" algn="bl" rotWithShape="0" blurRad="88900" dist="25400" dir="5400000">
+              <a:srgbClr val="0B140F">
+                <a:alpha val="16000"/>
+              </a:srgbClr>
+            </a:outerShdw>
+          </a:effectLst>
+        </p:spPr>
+      </p:sp>
+      <p:sp>
+        <p:nvSpPr>
+          <p:cNvPr id="12" name="Text 10"/>
+          <p:cNvSpPr/>
+          <p:nvPr/>
+        </p:nvSpPr>
+        <p:spPr>
+          <a:xfrm>
+            <a:off x="768096" y="4352544"/>
+            <a:ext cx="3136392" cy="320040"/>
+          </a:xfrm>
+          <a:prstGeom prst="rect">
+            <a:avLst/>
+          </a:prstGeom>
+          <a:noFill/>
+          <a:ln/>
+        </p:spPr>
+        <p:txBody>
+          <a:bodyPr wrap="square" lIns="0" tIns="0" rIns="0" bIns="0" rtlCol="0" anchor="ctr"/>
+          <a:lstStyle/>
+          <a:p>
+            <a:pPr indent="0" marL="0">
+              <a:buNone/>
+            </a:pPr>
+            <a:r>
+              <a:rPr lang="en-US" sz="1500" b="1" dirty="0">
                 <a:solidFill>
                   <a:srgbClr val="12857A"/>
                 </a:solidFill>
-                <a:latin typeface="Cambria" pitchFamily="34" charset="0"/>
-                <a:ea typeface="Cambria" pitchFamily="34" charset="-122"/>
-                <a:cs typeface="Cambria" pitchFamily="34" charset="-120"/>
-              </a:rPr>
-              <a:t>A2</a:t>
-            </a:r>
-            <a:endParaRPr lang="en-US" sz="3000" dirty="0"/>
-          </a:p>
-        </p:txBody>
-      </p:sp>
-      <p:sp>
-        <p:nvSpPr>
-          <p:cNvPr id="10" name="Text 8"/>
-          <p:cNvSpPr/>
-          <p:nvPr/>
-        </p:nvSpPr>
-        <p:spPr>
-          <a:xfrm>
-            <a:off x="1892808" y="4206240"/>
-            <a:ext cx="2286000" cy="640080"/>
+                <a:latin typeface="Calibri" pitchFamily="34" charset="0"/>
+                <a:ea typeface="Calibri" pitchFamily="34" charset="-122"/>
+                <a:cs typeface="Calibri" pitchFamily="34" charset="-120"/>
+              </a:rPr>
+              <a:t>🦠 Pathogen control</a:t>
+            </a:r>
+            <a:endParaRPr lang="en-US" sz="1500" dirty="0"/>
+          </a:p>
+        </p:txBody>
+      </p:sp>
+      <p:sp>
+        <p:nvSpPr>
+          <p:cNvPr id="13" name="Text 11"/>
+          <p:cNvSpPr/>
+          <p:nvPr/>
+        </p:nvSpPr>
+        <p:spPr>
+          <a:xfrm>
+            <a:off x="768096" y="4709160"/>
+            <a:ext cx="3136392" cy="685800"/>
           </a:xfrm>
           <a:prstGeom prst="rect">
             <a:avLst/>
@@ -17864,12 +19351,12 @@
           <a:p>
             <a:pPr indent="0" marL="0">
               <a:lnSpc>
-                <a:spcPct val="95000"/>
+                <a:spcPct val="103000"/>
               </a:lnSpc>
               <a:buNone/>
             </a:pPr>
             <a:r>
-              <a:rPr lang="en-US" sz="1250" b="1" dirty="0">
+              <a:rPr lang="en-US" sz="1250" dirty="0">
                 <a:solidFill>
                   <a:srgbClr val="39463E"/>
                 </a:solidFill>
@@ -17877,19 +19364,114 @@
                 <a:ea typeface="Calibri" pitchFamily="34" charset="-122"/>
                 <a:cs typeface="Calibri" pitchFamily="34" charset="-120"/>
               </a:rPr>
-              <a:t>Grass-fed hay milk</a:t>
+              <a:t>A dry, low-pH bed discourages harmful bacteria in the barn.</a:t>
             </a:r>
             <a:endParaRPr lang="en-US" sz="1250" dirty="0"/>
           </a:p>
+        </p:txBody>
+      </p:sp>
+      <p:sp>
+        <p:nvSpPr>
+          <p:cNvPr id="14" name="Shape 12"/>
+          <p:cNvSpPr/>
+          <p:nvPr/>
+        </p:nvSpPr>
+        <p:spPr>
+          <a:xfrm>
+            <a:off x="4251960" y="4206240"/>
+            <a:ext cx="3502152" cy="1280160"/>
+          </a:xfrm>
+          <a:prstGeom prst="roundRect">
+            <a:avLst>
+              <a:gd name="adj" fmla="val 7857"/>
+            </a:avLst>
+          </a:prstGeom>
+          <a:solidFill>
+            <a:srgbClr val="FFFFFF"/>
+          </a:solidFill>
+          <a:ln w="12700">
+            <a:solidFill>
+              <a:srgbClr val="E4E0D2"/>
+            </a:solidFill>
+            <a:prstDash val="solid"/>
+          </a:ln>
+          <a:effectLst>
+            <a:outerShdw sx="100000" sy="100000" kx="0" ky="0" algn="bl" rotWithShape="0" blurRad="88900" dist="25400" dir="5400000">
+              <a:srgbClr val="0B140F">
+                <a:alpha val="16000"/>
+              </a:srgbClr>
+            </a:outerShdw>
+          </a:effectLst>
+        </p:spPr>
+      </p:sp>
+      <p:sp>
+        <p:nvSpPr>
+          <p:cNvPr id="15" name="Text 13"/>
+          <p:cNvSpPr/>
+          <p:nvPr/>
+        </p:nvSpPr>
+        <p:spPr>
+          <a:xfrm>
+            <a:off x="4453128" y="4352544"/>
+            <a:ext cx="3136392" cy="320040"/>
+          </a:xfrm>
+          <a:prstGeom prst="rect">
+            <a:avLst/>
+          </a:prstGeom>
+          <a:noFill/>
+          <a:ln/>
+        </p:spPr>
+        <p:txBody>
+          <a:bodyPr wrap="square" lIns="0" tIns="0" rIns="0" bIns="0" rtlCol="0" anchor="ctr"/>
+          <a:lstStyle/>
+          <a:p>
+            <a:pPr indent="0" marL="0">
+              <a:buNone/>
+            </a:pPr>
+            <a:r>
+              <a:rPr lang="en-US" sz="1500" b="1" dirty="0">
+                <a:solidFill>
+                  <a:srgbClr val="3B5F22"/>
+                </a:solidFill>
+                <a:latin typeface="Calibri" pitchFamily="34" charset="0"/>
+                <a:ea typeface="Calibri" pitchFamily="34" charset="-122"/>
+                <a:cs typeface="Calibri" pitchFamily="34" charset="-120"/>
+              </a:rPr>
+              <a:t>♻️ Closes the loop</a:t>
+            </a:r>
+            <a:endParaRPr lang="en-US" sz="1500" dirty="0"/>
+          </a:p>
+        </p:txBody>
+      </p:sp>
+      <p:sp>
+        <p:nvSpPr>
+          <p:cNvPr id="16" name="Text 14"/>
+          <p:cNvSpPr/>
+          <p:nvPr/>
+        </p:nvSpPr>
+        <p:spPr>
+          <a:xfrm>
+            <a:off x="4453128" y="4709160"/>
+            <a:ext cx="3136392" cy="685800"/>
+          </a:xfrm>
+          <a:prstGeom prst="rect">
+            <a:avLst/>
+          </a:prstGeom>
+          <a:noFill/>
+          <a:ln/>
+        </p:spPr>
+        <p:txBody>
+          <a:bodyPr wrap="square" lIns="0" tIns="0" rIns="0" bIns="0" rtlCol="0" anchor="ctr"/>
+          <a:lstStyle/>
           <a:p>
             <a:pPr indent="0" marL="0">
               <a:lnSpc>
-                <a:spcPct val="95000"/>
+                <a:spcPct val="103000"/>
               </a:lnSpc>
               <a:buNone/>
             </a:pPr>
             <a:r>
-              <a:rPr lang="en-US" sz="1250" b="1" dirty="0">
+              <a:rPr lang="en-US" sz="1250" dirty="0">
                 <a:solidFill>
                   <a:srgbClr val="39463E"/>
                 </a:solidFill>
@@ -17897,7 +19479,7 @@
                 <a:ea typeface="Calibri" pitchFamily="34" charset="-122"/>
                 <a:cs typeface="Calibri" pitchFamily="34" charset="-120"/>
               </a:rPr>
-              <a:t>Jersey &amp; Holstein</a:t>
+              <a:t>Spent bedding + manure compost fast → back to the soil as fertiliser.</a:t>
             </a:r>
             <a:endParaRPr lang="en-US" sz="1250" dirty="0"/>
           </a:p>
@@ -17905,53 +19487,43 @@
       </p:sp>
       <p:sp>
         <p:nvSpPr>
-          <p:cNvPr id="11" name="Text 9"/>
-          <p:cNvSpPr/>
-          <p:nvPr/>
-        </p:nvSpPr>
-        <p:spPr>
-          <a:xfrm>
-            <a:off x="566928" y="5166360"/>
-            <a:ext cx="1280160" cy="548640"/>
-          </a:xfrm>
-          <a:prstGeom prst="rect">
-            <a:avLst/>
-          </a:prstGeom>
-          <a:noFill/>
-          <a:ln/>
-        </p:spPr>
-        <p:txBody>
-          <a:bodyPr wrap="square" lIns="0" tIns="0" rIns="0" bIns="0" rtlCol="0" anchor="ctr"/>
-          <a:lstStyle/>
-          <a:p>
-            <a:pPr algn="l" indent="0" marL="0">
-              <a:buNone/>
-            </a:pPr>
-            <a:r>
-              <a:rPr lang="en-US" sz="3000" b="1" dirty="0">
-                <a:solidFill>
-                  <a:srgbClr val="16221C"/>
-                </a:solidFill>
-                <a:latin typeface="Cambria" pitchFamily="34" charset="0"/>
-                <a:ea typeface="Cambria" pitchFamily="34" charset="-122"/>
-                <a:cs typeface="Cambria" pitchFamily="34" charset="-120"/>
-              </a:rPr>
-              <a:t>🤖</a:t>
-            </a:r>
-            <a:endParaRPr lang="en-US" sz="3000" dirty="0"/>
-          </a:p>
-        </p:txBody>
-      </p:sp>
-      <p:sp>
-        <p:nvSpPr>
-          <p:cNvPr id="12" name="Text 10"/>
-          <p:cNvSpPr/>
-          <p:nvPr/>
-        </p:nvSpPr>
-        <p:spPr>
-          <a:xfrm>
-            <a:off x="1892808" y="5166360"/>
-            <a:ext cx="2286000" cy="640080"/>
+          <p:cNvPr id="17" name="Shape 15"/>
+          <p:cNvSpPr/>
+          <p:nvPr/>
+        </p:nvSpPr>
+        <p:spPr>
+          <a:xfrm>
+            <a:off x="566928" y="5532120"/>
+            <a:ext cx="7187184" cy="822960"/>
+          </a:xfrm>
+          <a:prstGeom prst="roundRect">
+            <a:avLst>
+              <a:gd name="adj" fmla="val 12222"/>
+            </a:avLst>
+          </a:prstGeom>
+          <a:solidFill>
+            <a:srgbClr val="F1E9DD"/>
+          </a:solidFill>
+          <a:ln/>
+          <a:effectLst>
+            <a:outerShdw sx="100000" sy="100000" kx="0" ky="0" algn="bl" rotWithShape="0" blurRad="88900" dist="25400" dir="5400000">
+              <a:srgbClr val="0B140F">
+                <a:alpha val="16000"/>
+              </a:srgbClr>
+            </a:outerShdw>
+          </a:effectLst>
+        </p:spPr>
+      </p:sp>
+      <p:sp>
+        <p:nvSpPr>
+          <p:cNvPr id="18" name="Text 16"/>
+          <p:cNvSpPr/>
+          <p:nvPr/>
+        </p:nvSpPr>
+        <p:spPr>
+          <a:xfrm>
+            <a:off x="795528" y="5623560"/>
+            <a:ext cx="6766560" cy="640080"/>
           </a:xfrm>
           <a:prstGeom prst="rect">
             <a:avLst/>
@@ -17965,32 +19537,29 @@
           <a:p>
             <a:pPr indent="0" marL="0">
               <a:lnSpc>
-                <a:spcPct val="95000"/>
+                <a:spcPct val="105000"/>
               </a:lnSpc>
               <a:buNone/>
             </a:pPr>
             <a:r>
               <a:rPr lang="en-US" sz="1250" b="1" dirty="0">
                 <a:solidFill>
-                  <a:srgbClr val="39463E"/>
-                </a:solidFill>
-                <a:latin typeface="Calibri" pitchFamily="34" charset="0"/>
-                <a:ea typeface="Calibri" pitchFamily="34" charset="-122"/>
-                <a:cs typeface="Calibri" pitchFamily="34" charset="-120"/>
-              </a:rPr>
-              <a:t>Robotic milking —</a:t>
-            </a:r>
-            <a:endParaRPr lang="en-US" sz="1250" dirty="0"/>
-          </a:p>
-          <a:p>
+                  <a:srgbClr val="9A6B3A"/>
+                </a:solidFill>
+                <a:latin typeface="Calibri" pitchFamily="34" charset="0"/>
+                <a:ea typeface="Calibri" pitchFamily="34" charset="-122"/>
+                <a:cs typeface="Calibri" pitchFamily="34" charset="-120"/>
+              </a:rPr>
+              <a:t>For Vietnam:  </a:t>
+            </a:r>
             <a:pPr indent="0" marL="0">
               <a:lnSpc>
-                <a:spcPct val="95000"/>
+                <a:spcPct val="105000"/>
               </a:lnSpc>
               <a:buNone/>
             </a:pPr>
             <a:r>
-              <a:rPr lang="en-US" sz="1250" b="1" dirty="0">
+              <a:rPr lang="en-US" sz="1250" dirty="0">
                 <a:solidFill>
                   <a:srgbClr val="39463E"/>
                 </a:solidFill>
@@ -17998,7 +19567,7 @@
                 <a:ea typeface="Calibri" pitchFamily="34" charset="-122"/>
                 <a:cs typeface="Calibri" pitchFamily="34" charset="-120"/>
               </a:rPr>
-              <a:t>cows choose their time</a:t>
+              <a:t>in a hot, humid climate moisture &amp; odour are the barn's first problem — HBP improves welfare and the environment together.</a:t>
             </a:r>
             <a:endParaRPr lang="en-US" sz="1250" dirty="0"/>
           </a:p>
@@ -18006,18 +19575,18 @@
       </p:sp>
       <p:sp>
         <p:nvSpPr>
-          <p:cNvPr id="13" name="Shape 11"/>
-          <p:cNvSpPr/>
-          <p:nvPr/>
-        </p:nvSpPr>
-        <p:spPr>
-          <a:xfrm>
-            <a:off x="4160520" y="2240280"/>
-            <a:ext cx="3639312" cy="1965960"/>
+          <p:cNvPr id="19" name="Shape 17"/>
+          <p:cNvSpPr/>
+          <p:nvPr/>
+        </p:nvSpPr>
+        <p:spPr>
+          <a:xfrm>
+            <a:off x="8183880" y="1280160"/>
+            <a:ext cx="3456432" cy="5029200"/>
           </a:xfrm>
           <a:prstGeom prst="roundRect">
             <a:avLst>
-              <a:gd name="adj" fmla="val 4186"/>
+              <a:gd name="adj" fmla="val 2381"/>
             </a:avLst>
           </a:prstGeom>
           <a:solidFill>
@@ -18035,7 +19604,7 @@
       </p:sp>
       <p:pic>
         <p:nvPicPr>
-          <p:cNvPr id="14" name="Image 0" descr="/tmp/claude-0/-home-user-Dr-Ha--agent/6665ef24-eca8-582e-bc7a-8ce8fc2f76de/scratchpad/opt/aerial.jpg">    </p:cNvPr>
+          <p:cNvPr id="20" name="Image 0" descr="/tmp/claude-0/-home-user-Dr-Ha--agent/6665ef24-eca8-582e-bc7a-8ce8fc2f76de/scratchpad/opt/syjersey.jpg">    </p:cNvPr>
           <p:cNvPicPr>
             <a:picLocks noChangeAspect="1"/>
           </p:cNvPicPr>
@@ -18048,8 +19617,8 @@
         </p:blipFill>
         <p:spPr>
           <a:xfrm>
-            <a:off x="4178808" y="2258568"/>
-            <a:ext cx="3602736" cy="1929384"/>
+            <a:off x="8202168" y="1298448"/>
+            <a:ext cx="3419856" cy="4992624"/>
           </a:xfrm>
           <a:prstGeom prst="rect">
             <a:avLst/>
@@ -18058,14 +19627,14 @@
       </p:pic>
       <p:sp>
         <p:nvSpPr>
-          <p:cNvPr id="15" name="Shape 12"/>
-          <p:cNvSpPr/>
-          <p:nvPr/>
-        </p:nvSpPr>
-        <p:spPr>
-          <a:xfrm>
-            <a:off x="4297680" y="2377440"/>
-            <a:ext cx="746150" cy="310896"/>
+          <p:cNvPr id="21" name="Shape 18"/>
+          <p:cNvSpPr/>
+          <p:nvPr/>
+        </p:nvSpPr>
+        <p:spPr>
+          <a:xfrm>
+            <a:off x="8321040" y="1417320"/>
+            <a:ext cx="2470709" cy="310896"/>
           </a:xfrm>
           <a:prstGeom prst="roundRect">
             <a:avLst>
@@ -18082,14 +19651,14 @@
       </p:sp>
       <p:sp>
         <p:nvSpPr>
-          <p:cNvPr id="16" name="Text 13"/>
-          <p:cNvSpPr/>
-          <p:nvPr/>
-        </p:nvSpPr>
-        <p:spPr>
-          <a:xfrm>
-            <a:off x="4297680" y="2377440"/>
-            <a:ext cx="746150" cy="310896"/>
+          <p:cNvPr id="22" name="Text 19"/>
+          <p:cNvSpPr/>
+          <p:nvPr/>
+        </p:nvSpPr>
+        <p:spPr>
+          <a:xfrm>
+            <a:off x="8321040" y="1417320"/>
+            <a:ext cx="2470709" cy="310896"/>
           </a:xfrm>
           <a:prstGeom prst="rect">
             <a:avLst/>
@@ -18113,7 +19682,7 @@
                 <a:ea typeface="Calibri" pitchFamily="34" charset="-122"/>
                 <a:cs typeface="Calibri" pitchFamily="34" charset="-120"/>
               </a:rPr>
-              <a:t>THE FARM</a:t>
+              <a:t>PEAT-MOSS BEDDING · JERSEY BARN</a:t>
             </a:r>
             <a:endParaRPr lang="en-US" sz="950" dirty="0"/>
           </a:p>
@@ -18121,352 +19690,7 @@
       </p:sp>
       <p:sp>
         <p:nvSpPr>
-          <p:cNvPr id="17" name="Shape 14"/>
-          <p:cNvSpPr/>
-          <p:nvPr/>
-        </p:nvSpPr>
-        <p:spPr>
-          <a:xfrm>
-            <a:off x="7982712" y="2240280"/>
-            <a:ext cx="3639312" cy="1965960"/>
-          </a:xfrm>
-          <a:prstGeom prst="roundRect">
-            <a:avLst>
-              <a:gd name="adj" fmla="val 4186"/>
-            </a:avLst>
-          </a:prstGeom>
-          <a:solidFill>
-            <a:srgbClr val="ECE7DA"/>
-          </a:solidFill>
-          <a:ln/>
-          <a:effectLst>
-            <a:outerShdw sx="100000" sy="100000" kx="0" ky="0" algn="bl" rotWithShape="0" blurRad="101600" dist="25400" dir="5400000">
-              <a:srgbClr val="0B140F">
-                <a:alpha val="22000"/>
-              </a:srgbClr>
-            </a:outerShdw>
-          </a:effectLst>
-        </p:spPr>
-      </p:sp>
-      <p:pic>
-        <p:nvPicPr>
-          <p:cNvPr id="18" name="Image 1" descr="/tmp/claude-0/-home-user-Dr-Ha--agent/6665ef24-eca8-582e-bc7a-8ce8fc2f76de/scratchpad/opt/grassland.jpg">    </p:cNvPr>
-          <p:cNvPicPr>
-            <a:picLocks noChangeAspect="1"/>
-          </p:cNvPicPr>
-          <p:nvPr/>
-        </p:nvPicPr>
-        <p:blipFill>
-          <a:blip r:embed="rId2"/>
-          <a:srcRect l="0" r="0" t="0" b="0"/>
-          <a:stretch/>
-        </p:blipFill>
-        <p:spPr>
-          <a:xfrm>
-            <a:off x="8001000" y="2258568"/>
-            <a:ext cx="3602736" cy="1929384"/>
-          </a:xfrm>
-          <a:prstGeom prst="rect">
-            <a:avLst/>
-          </a:prstGeom>
-        </p:spPr>
-      </p:pic>
-      <p:sp>
-        <p:nvSpPr>
-          <p:cNvPr id="19" name="Shape 15"/>
-          <p:cNvSpPr/>
-          <p:nvPr/>
-        </p:nvSpPr>
-        <p:spPr>
-          <a:xfrm>
-            <a:off x="8119872" y="2377440"/>
-            <a:ext cx="1271016" cy="310896"/>
-          </a:xfrm>
-          <a:prstGeom prst="roundRect">
-            <a:avLst>
-              <a:gd name="adj" fmla="val 17647"/>
-            </a:avLst>
-          </a:prstGeom>
-          <a:solidFill>
-            <a:srgbClr val="0E1F18">
-              <a:alpha val="86000"/>
-            </a:srgbClr>
-          </a:solidFill>
-          <a:ln/>
-        </p:spPr>
-      </p:sp>
-      <p:sp>
-        <p:nvSpPr>
-          <p:cNvPr id="20" name="Text 16"/>
-          <p:cNvSpPr/>
-          <p:nvPr/>
-        </p:nvSpPr>
-        <p:spPr>
-          <a:xfrm>
-            <a:off x="8119872" y="2377440"/>
-            <a:ext cx="1271016" cy="310896"/>
-          </a:xfrm>
-          <a:prstGeom prst="rect">
-            <a:avLst/>
-          </a:prstGeom>
-          <a:noFill/>
-          <a:ln/>
-        </p:spPr>
-        <p:txBody>
-          <a:bodyPr wrap="square" lIns="0" tIns="0" rIns="0" bIns="0" rtlCol="0" anchor="ctr"/>
-          <a:lstStyle/>
-          <a:p>
-            <a:pPr algn="ctr" indent="0" marL="0">
-              <a:buNone/>
-            </a:pPr>
-            <a:r>
-              <a:rPr lang="en-US" sz="950" b="1" spc="120" kern="0" dirty="0">
-                <a:solidFill>
-                  <a:srgbClr val="F6F3EA"/>
-                </a:solidFill>
-                <a:latin typeface="Calibri" pitchFamily="34" charset="0"/>
-                <a:ea typeface="Calibri" pitchFamily="34" charset="-122"/>
-                <a:cs typeface="Calibri" pitchFamily="34" charset="-120"/>
-              </a:rPr>
-              <a:t>30 HA GRASSLAND</a:t>
-            </a:r>
-            <a:endParaRPr lang="en-US" sz="950" dirty="0"/>
-          </a:p>
-        </p:txBody>
-      </p:sp>
-      <p:sp>
-        <p:nvSpPr>
-          <p:cNvPr id="21" name="Shape 17"/>
-          <p:cNvSpPr/>
-          <p:nvPr/>
-        </p:nvSpPr>
-        <p:spPr>
-          <a:xfrm>
-            <a:off x="4160520" y="4389120"/>
-            <a:ext cx="3639312" cy="1965960"/>
-          </a:xfrm>
-          <a:prstGeom prst="roundRect">
-            <a:avLst>
-              <a:gd name="adj" fmla="val 4186"/>
-            </a:avLst>
-          </a:prstGeom>
-          <a:solidFill>
-            <a:srgbClr val="ECE7DA"/>
-          </a:solidFill>
-          <a:ln/>
-          <a:effectLst>
-            <a:outerShdw sx="100000" sy="100000" kx="0" ky="0" algn="bl" rotWithShape="0" blurRad="101600" dist="25400" dir="5400000">
-              <a:srgbClr val="0B140F">
-                <a:alpha val="22000"/>
-              </a:srgbClr>
-            </a:outerShdw>
-          </a:effectLst>
-        </p:spPr>
-      </p:sp>
-      <p:pic>
-        <p:nvPicPr>
-          <p:cNvPr id="22" name="Image 2" descr="/tmp/claude-0/-home-user-Dr-Ha--agent/6665ef24-eca8-582e-bc7a-8ce8fc2f76de/scratchpad/opt/robot.jpg">    </p:cNvPr>
-          <p:cNvPicPr>
-            <a:picLocks noChangeAspect="1"/>
-          </p:cNvPicPr>
-          <p:nvPr/>
-        </p:nvPicPr>
-        <p:blipFill>
-          <a:blip r:embed="rId3"/>
-          <a:srcRect l="0" r="0" t="0" b="0"/>
-          <a:stretch/>
-        </p:blipFill>
-        <p:spPr>
-          <a:xfrm>
-            <a:off x="4178808" y="4407408"/>
-            <a:ext cx="3602736" cy="1929384"/>
-          </a:xfrm>
-          <a:prstGeom prst="rect">
-            <a:avLst/>
-          </a:prstGeom>
-        </p:spPr>
-      </p:pic>
-      <p:sp>
-        <p:nvSpPr>
-          <p:cNvPr id="23" name="Shape 18"/>
-          <p:cNvSpPr/>
-          <p:nvPr/>
-        </p:nvSpPr>
-        <p:spPr>
-          <a:xfrm>
-            <a:off x="4297680" y="4526280"/>
-            <a:ext cx="1271016" cy="310896"/>
-          </a:xfrm>
-          <a:prstGeom prst="roundRect">
-            <a:avLst>
-              <a:gd name="adj" fmla="val 17647"/>
-            </a:avLst>
-          </a:prstGeom>
-          <a:solidFill>
-            <a:srgbClr val="0E1F18">
-              <a:alpha val="86000"/>
-            </a:srgbClr>
-          </a:solidFill>
-          <a:ln/>
-        </p:spPr>
-      </p:sp>
-      <p:sp>
-        <p:nvSpPr>
-          <p:cNvPr id="24" name="Text 19"/>
-          <p:cNvSpPr/>
-          <p:nvPr/>
-        </p:nvSpPr>
-        <p:spPr>
-          <a:xfrm>
-            <a:off x="4297680" y="4526280"/>
-            <a:ext cx="1271016" cy="310896"/>
-          </a:xfrm>
-          <a:prstGeom prst="rect">
-            <a:avLst/>
-          </a:prstGeom>
-          <a:noFill/>
-          <a:ln/>
-        </p:spPr>
-        <p:txBody>
-          <a:bodyPr wrap="square" lIns="0" tIns="0" rIns="0" bIns="0" rtlCol="0" anchor="ctr"/>
-          <a:lstStyle/>
-          <a:p>
-            <a:pPr algn="ctr" indent="0" marL="0">
-              <a:buNone/>
-            </a:pPr>
-            <a:r>
-              <a:rPr lang="en-US" sz="950" b="1" spc="120" kern="0" dirty="0">
-                <a:solidFill>
-                  <a:srgbClr val="F6F3EA"/>
-                </a:solidFill>
-                <a:latin typeface="Calibri" pitchFamily="34" charset="0"/>
-                <a:ea typeface="Calibri" pitchFamily="34" charset="-122"/>
-                <a:cs typeface="Calibri" pitchFamily="34" charset="-120"/>
-              </a:rPr>
-              <a:t>ROBOTIC MILKING</a:t>
-            </a:r>
-            <a:endParaRPr lang="en-US" sz="950" dirty="0"/>
-          </a:p>
-        </p:txBody>
-      </p:sp>
-      <p:sp>
-        <p:nvSpPr>
-          <p:cNvPr id="25" name="Shape 20"/>
-          <p:cNvSpPr/>
-          <p:nvPr/>
-        </p:nvSpPr>
-        <p:spPr>
-          <a:xfrm>
-            <a:off x="7982712" y="4389120"/>
-            <a:ext cx="3639312" cy="1965960"/>
-          </a:xfrm>
-          <a:prstGeom prst="roundRect">
-            <a:avLst>
-              <a:gd name="adj" fmla="val 4186"/>
-            </a:avLst>
-          </a:prstGeom>
-          <a:solidFill>
-            <a:srgbClr val="ECE7DA"/>
-          </a:solidFill>
-          <a:ln/>
-          <a:effectLst>
-            <a:outerShdw sx="100000" sy="100000" kx="0" ky="0" algn="bl" rotWithShape="0" blurRad="101600" dist="25400" dir="5400000">
-              <a:srgbClr val="0B140F">
-                <a:alpha val="22000"/>
-              </a:srgbClr>
-            </a:outerShdw>
-          </a:effectLst>
-        </p:spPr>
-      </p:sp>
-      <p:pic>
-        <p:nvPicPr>
-          <p:cNvPr id="26" name="Image 3" descr="/tmp/claude-0/-home-user-Dr-Ha--agent/6665ef24-eca8-582e-bc7a-8ce8fc2f76de/scratchpad/opt/grassfed.jpg">    </p:cNvPr>
-          <p:cNvPicPr>
-            <a:picLocks noChangeAspect="1"/>
-          </p:cNvPicPr>
-          <p:nvPr/>
-        </p:nvPicPr>
-        <p:blipFill>
-          <a:blip r:embed="rId4"/>
-          <a:srcRect l="0" r="0" t="0" b="0"/>
-          <a:stretch/>
-        </p:blipFill>
-        <p:spPr>
-          <a:xfrm>
-            <a:off x="8001000" y="4407408"/>
-            <a:ext cx="3602736" cy="1929384"/>
-          </a:xfrm>
-          <a:prstGeom prst="rect">
-            <a:avLst/>
-          </a:prstGeom>
-        </p:spPr>
-      </p:pic>
-      <p:sp>
-        <p:nvSpPr>
-          <p:cNvPr id="27" name="Shape 21"/>
-          <p:cNvSpPr/>
-          <p:nvPr/>
-        </p:nvSpPr>
-        <p:spPr>
-          <a:xfrm>
-            <a:off x="8119872" y="4526280"/>
-            <a:ext cx="1196035" cy="310896"/>
-          </a:xfrm>
-          <a:prstGeom prst="roundRect">
-            <a:avLst>
-              <a:gd name="adj" fmla="val 17647"/>
-            </a:avLst>
-          </a:prstGeom>
-          <a:solidFill>
-            <a:srgbClr val="0E1F18">
-              <a:alpha val="86000"/>
-            </a:srgbClr>
-          </a:solidFill>
-          <a:ln/>
-        </p:spPr>
-      </p:sp>
-      <p:sp>
-        <p:nvSpPr>
-          <p:cNvPr id="28" name="Text 22"/>
-          <p:cNvSpPr/>
-          <p:nvPr/>
-        </p:nvSpPr>
-        <p:spPr>
-          <a:xfrm>
-            <a:off x="8119872" y="4526280"/>
-            <a:ext cx="1196035" cy="310896"/>
-          </a:xfrm>
-          <a:prstGeom prst="rect">
-            <a:avLst/>
-          </a:prstGeom>
-          <a:noFill/>
-          <a:ln/>
-        </p:spPr>
-        <p:txBody>
-          <a:bodyPr wrap="square" lIns="0" tIns="0" rIns="0" bIns="0" rtlCol="0" anchor="ctr"/>
-          <a:lstStyle/>
-          <a:p>
-            <a:pPr algn="ctr" indent="0" marL="0">
-              <a:buNone/>
-            </a:pPr>
-            <a:r>
-              <a:rPr lang="en-US" sz="950" b="1" spc="120" kern="0" dirty="0">
-                <a:solidFill>
-                  <a:srgbClr val="F6F3EA"/>
-                </a:solidFill>
-                <a:latin typeface="Calibri" pitchFamily="34" charset="0"/>
-                <a:ea typeface="Calibri" pitchFamily="34" charset="-122"/>
-                <a:cs typeface="Calibri" pitchFamily="34" charset="-120"/>
-              </a:rPr>
-              <a:t>100% GRASS-FED</a:t>
-            </a:r>
-            <a:endParaRPr lang="en-US" sz="950" dirty="0"/>
-          </a:p>
-        </p:txBody>
-      </p:sp>
-      <p:sp>
-        <p:nvSpPr>
-          <p:cNvPr id="29" name="Text 23"/>
+          <p:cNvPr id="23" name="Text 20"/>
           <p:cNvSpPr/>
           <p:nvPr/>
         </p:nvSpPr>
@@ -18497,7 +19721,7 @@
                 <a:ea typeface="Calibri" pitchFamily="34" charset="-122"/>
                 <a:cs typeface="Calibri" pitchFamily="34" charset="-120"/>
               </a:rPr>
-              <a:t>SUSTAINABLE DAIRY</a:t>
+              <a:t>HBP · PEAT-MOSS BEDDING</a:t>
             </a:r>
             <a:endParaRPr lang="en-US" sz="1000" dirty="0"/>
           </a:p>
@@ -18505,7 +19729,7 @@
       </p:sp>
       <p:sp>
         <p:nvSpPr>
-          <p:cNvPr id="30" name="Text 24"/>
+          <p:cNvPr id="24" name="Text 21"/>
           <p:cNvSpPr/>
           <p:nvPr/>
         </p:nvSpPr>

</xml_diff>